<commit_message>
docs: align documentation and publications with September evidence
</commit_message>
<xml_diff>
--- a/docs/publishing/executive-briefing/files/engineering-governance-presentation.pptx
+++ b/docs/publishing/executive-briefing/files/engineering-governance-presentation.pptx
@@ -2,24 +2,24 @@
 <file path=ppt/presentation.xml><?xml version="1.0" encoding="utf-8"?>
 <p:presentation xmlns:p="http://schemas.openxmlformats.org/presentationml/2006/main">
   <p:sldMasterIdLst>
-    <p:sldMasterId xmlns:r="http://schemas.openxmlformats.org/officeDocument/2006/relationships" id="2147483648" r:id="R886147208ac24177"/>
+    <p:sldMasterId xmlns:r="http://schemas.openxmlformats.org/officeDocument/2006/relationships" id="2147483648" r:id="Rb90599b7f2104654"/>
   </p:sldMasterIdLst>
   <p:notesMasterIdLst>
-    <p:notesMasterId xmlns:r="http://schemas.openxmlformats.org/officeDocument/2006/relationships" r:id="R426c78d0bf5f467a"/>
+    <p:notesMasterId xmlns:r="http://schemas.openxmlformats.org/officeDocument/2006/relationships" r:id="R18e912e2d3dd40d2"/>
   </p:notesMasterIdLst>
   <p:sldIdLst>
-    <p:sldId xmlns:r="http://schemas.openxmlformats.org/officeDocument/2006/relationships" id="256" r:id="R8a34c16d867b416e"/>
-    <p:sldId xmlns:r="http://schemas.openxmlformats.org/officeDocument/2006/relationships" id="257" r:id="R92c1c29560c04730"/>
-    <p:sldId xmlns:r="http://schemas.openxmlformats.org/officeDocument/2006/relationships" id="258" r:id="R5565d2f79c3041e8"/>
-    <p:sldId xmlns:r="http://schemas.openxmlformats.org/officeDocument/2006/relationships" id="259" r:id="R52b32c58b02941f0"/>
-    <p:sldId xmlns:r="http://schemas.openxmlformats.org/officeDocument/2006/relationships" id="260" r:id="Raecbb447aaf24574"/>
-    <p:sldId xmlns:r="http://schemas.openxmlformats.org/officeDocument/2006/relationships" id="261" r:id="Rf9effcf475724e63"/>
-    <p:sldId xmlns:r="http://schemas.openxmlformats.org/officeDocument/2006/relationships" id="262" r:id="Rebf783a682a74b20"/>
-    <p:sldId xmlns:r="http://schemas.openxmlformats.org/officeDocument/2006/relationships" id="263" r:id="R5501597d43ee4e0d"/>
-    <p:sldId xmlns:r="http://schemas.openxmlformats.org/officeDocument/2006/relationships" id="264" r:id="R9a74e1a453cb4ce1"/>
-    <p:sldId xmlns:r="http://schemas.openxmlformats.org/officeDocument/2006/relationships" id="265" r:id="Rb73c86fd404542f6"/>
-    <p:sldId xmlns:r="http://schemas.openxmlformats.org/officeDocument/2006/relationships" id="266" r:id="Rcaa640de0cf44733"/>
-    <p:sldId xmlns:r="http://schemas.openxmlformats.org/officeDocument/2006/relationships" id="267" r:id="R0c7c7bc59e224eae"/>
+    <p:sldId xmlns:r="http://schemas.openxmlformats.org/officeDocument/2006/relationships" id="256" r:id="R279f3672d6174d2e"/>
+    <p:sldId xmlns:r="http://schemas.openxmlformats.org/officeDocument/2006/relationships" id="257" r:id="R3a4a471ba2a54584"/>
+    <p:sldId xmlns:r="http://schemas.openxmlformats.org/officeDocument/2006/relationships" id="258" r:id="Rfab56cc9c0b64536"/>
+    <p:sldId xmlns:r="http://schemas.openxmlformats.org/officeDocument/2006/relationships" id="259" r:id="Rbc074808c1784189"/>
+    <p:sldId xmlns:r="http://schemas.openxmlformats.org/officeDocument/2006/relationships" id="260" r:id="R0defbd9d61df4426"/>
+    <p:sldId xmlns:r="http://schemas.openxmlformats.org/officeDocument/2006/relationships" id="261" r:id="Rcdad902a3ef648f3"/>
+    <p:sldId xmlns:r="http://schemas.openxmlformats.org/officeDocument/2006/relationships" id="262" r:id="R7f1865abd1154ff7"/>
+    <p:sldId xmlns:r="http://schemas.openxmlformats.org/officeDocument/2006/relationships" id="263" r:id="R9b892179c82b4059"/>
+    <p:sldId xmlns:r="http://schemas.openxmlformats.org/officeDocument/2006/relationships" id="264" r:id="R4bc947b6cade4c48"/>
+    <p:sldId xmlns:r="http://schemas.openxmlformats.org/officeDocument/2006/relationships" id="265" r:id="R4ab201b0c361474d"/>
+    <p:sldId xmlns:r="http://schemas.openxmlformats.org/officeDocument/2006/relationships" id="266" r:id="R988722dfd3634b91"/>
+    <p:sldId xmlns:r="http://schemas.openxmlformats.org/officeDocument/2006/relationships" id="267" r:id="R6d6d1202e7074c07"/>
   </p:sldIdLst>
   <p:sldSz cx="12192000" cy="6858000"/>
   <p:notesSz cx="6858000" cy="9144000"/>
@@ -453,7 +453,7 @@
           <a:lstStyle xmlns:a="http://schemas.openxmlformats.org/drawingml/2006/main"/>
           <a:p xmlns:a="http://schemas.openxmlformats.org/drawingml/2006/main">
             <a:r>
-              <a:t>Ziel ist eine Entscheidung über einen kontrollierten Testbetrieb. Die Plattform verbindet fachliche Vorgaben mit ausgewählten automatisierten Prüfungen. Der Vortrag beschreibt den Stand vom 9. September 2026 und keine bestätigte unternehmensweite Betriebsreife.</a:t>
+              <a:t>Ziel ist eine Entscheidung über einen kontrollierten Testbetrieb. Die Plattform verbindet fachliche Vorgaben mit ausgewählten automatisierten Prüfungen. Der Vortrag beschreibt den Stand vom 11. September 2026 und keine bestätigte unternehmensweite Betriebsreife.</a:t>
             </a:r>
           </a:p>
           <a:p xmlns:a="http://schemas.openxmlformats.org/drawingml/2006/main">
@@ -463,7 +463,7 @@
           </a:p>
           <a:p xmlns:a="http://schemas.openxmlformats.org/drawingml/2006/main">
             <a:r>
-              <a:t>Quellstand: 689357712b8eaaa91968a6810c7f056adb6f6555</a:t>
+              <a:t>Quellstand: 4abe88294f299d7f801c74ff0161df234960c092</a:t>
             </a:r>
           </a:p>
           <a:p xmlns:a="http://schemas.openxmlformats.org/drawingml/2006/main">
@@ -473,7 +473,7 @@
           </a:p>
           <a:p xmlns:a="http://schemas.openxmlformats.org/drawingml/2006/main">
             <a:r>
-              <a:t>https://github.com/joku-dev/devsecops-governance-framework/blob/689357712b8eaaa91968a6810c7f056adb6f6555/docs/foundation/05_CURRENT_DIRECTION.md</a:t>
+              <a:t>https://github.com/joku-dev/devsecops-governance-framework/blob/4abe88294f299d7f801c74ff0161df234960c092/docs/foundation/05_CURRENT_DIRECTION.md</a:t>
             </a:r>
           </a:p>
           <a:p xmlns:a="http://schemas.openxmlformats.org/drawingml/2006/main">
@@ -488,7 +488,7 @@
           </a:p>
           <a:p xmlns:a="http://schemas.openxmlformats.org/drawingml/2006/main">
             <a:r>
-              <a:t>https://github.com/joku-dev/devsecops-governance-framework/blob/689357712b8eaaa91968a6810c7f056adb6f6555/docs/operations/guides/governance-repository-operations-handbook.md</a:t>
+              <a:t>https://github.com/joku-dev/devsecops-governance-framework/blob/4abe88294f299d7f801c74ff0161df234960c092/docs/operations/guides/governance-repository-operations-handbook.md</a:t>
             </a:r>
           </a:p>
         </p:txBody>
@@ -568,7 +568,7 @@
           </a:p>
           <a:p xmlns:a="http://schemas.openxmlformats.org/drawingml/2006/main">
             <a:r>
-              <a:t>Quellstand: 689357712b8eaaa91968a6810c7f056adb6f6555</a:t>
+              <a:t>Quellstand: 4abe88294f299d7f801c74ff0161df234960c092</a:t>
             </a:r>
           </a:p>
           <a:p xmlns:a="http://schemas.openxmlformats.org/drawingml/2006/main">
@@ -578,7 +578,7 @@
           </a:p>
           <a:p xmlns:a="http://schemas.openxmlformats.org/drawingml/2006/main">
             <a:r>
-              <a:t>https://github.com/joku-dev/devsecops-governance-framework/blob/689357712b8eaaa91968a6810c7f056adb6f6555/docs/operations/guides/governance-repository-operations-handbook.md</a:t>
+              <a:t>https://github.com/joku-dev/devsecops-governance-framework/blob/4abe88294f299d7f801c74ff0161df234960c092/docs/operations/guides/governance-repository-operations-handbook.md</a:t>
             </a:r>
           </a:p>
           <a:p xmlns:a="http://schemas.openxmlformats.org/drawingml/2006/main">
@@ -593,7 +593,7 @@
           </a:p>
           <a:p xmlns:a="http://schemas.openxmlformats.org/drawingml/2006/main">
             <a:r>
-              <a:t>https://github.com/joku-dev/devsecops-governance-framework/blob/689357712b8eaaa91968a6810c7f056adb6f6555/docs/operations/evidence/governance-result-intake-and-viewer-usage.md</a:t>
+              <a:t>https://github.com/joku-dev/devsecops-governance-framework/blob/4abe88294f299d7f801c74ff0161df234960c092/docs/operations/evidence/governance-result-intake-and-viewer-usage.md</a:t>
             </a:r>
           </a:p>
           <a:p xmlns:a="http://schemas.openxmlformats.org/drawingml/2006/main">
@@ -608,7 +608,7 @@
           </a:p>
           <a:p xmlns:a="http://schemas.openxmlformats.org/drawingml/2006/main">
             <a:r>
-              <a:t>https://github.com/joku-dev/devsecops-governance-framework/blob/689357712b8eaaa91968a6810c7f056adb6f6555/docs/operations/processes/governance-repository-backup-and-recovery.md</a:t>
+              <a:t>https://github.com/joku-dev/devsecops-governance-framework/blob/4abe88294f299d7f801c74ff0161df234960c092/docs/operations/processes/governance-repository-backup-and-recovery.md</a:t>
             </a:r>
           </a:p>
         </p:txBody>
@@ -688,7 +688,7 @@
           </a:p>
           <a:p xmlns:a="http://schemas.openxmlformats.org/drawingml/2006/main">
             <a:r>
-              <a:t>Quellstand: 689357712b8eaaa91968a6810c7f056adb6f6555</a:t>
+              <a:t>Quellstand: 4abe88294f299d7f801c74ff0161df234960c092</a:t>
             </a:r>
           </a:p>
           <a:p xmlns:a="http://schemas.openxmlformats.org/drawingml/2006/main">
@@ -698,7 +698,7 @@
           </a:p>
           <a:p xmlns:a="http://schemas.openxmlformats.org/drawingml/2006/main">
             <a:r>
-              <a:t>https://github.com/joku-dev/devsecops-governance-framework/blob/689357712b8eaaa91968a6810c7f056adb6f6555/docs/operations/guides/governance-repository-operations-handbook.md</a:t>
+              <a:t>https://github.com/joku-dev/devsecops-governance-framework/blob/4abe88294f299d7f801c74ff0161df234960c092/docs/operations/guides/governance-repository-operations-handbook.md</a:t>
             </a:r>
           </a:p>
           <a:p xmlns:a="http://schemas.openxmlformats.org/drawingml/2006/main">
@@ -713,7 +713,7 @@
           </a:p>
           <a:p xmlns:a="http://schemas.openxmlformats.org/drawingml/2006/main">
             <a:r>
-              <a:t>https://github.com/joku-dev/devsecops-governance-framework/blob/689357712b8eaaa91968a6810c7f056adb6f6555/docs/operations/status/daily-governance-operations.md</a:t>
+              <a:t>https://github.com/joku-dev/devsecops-governance-framework/blob/4abe88294f299d7f801c74ff0161df234960c092/docs/operations/status/daily-governance-operations.md</a:t>
             </a:r>
           </a:p>
           <a:p xmlns:a="http://schemas.openxmlformats.org/drawingml/2006/main">
@@ -728,7 +728,7 @@
           </a:p>
           <a:p xmlns:a="http://schemas.openxmlformats.org/drawingml/2006/main">
             <a:r>
-              <a:t>https://github.com/joku-dev/devsecops-governance-framework/blob/689357712b8eaaa91968a6810c7f056adb6f6555/docs/operations/processes/governance-repository-backup-and-recovery.md</a:t>
+              <a:t>https://github.com/joku-dev/devsecops-governance-framework/blob/4abe88294f299d7f801c74ff0161df234960c092/docs/operations/processes/governance-repository-backup-and-recovery.md</a:t>
             </a:r>
           </a:p>
           <a:p xmlns:a="http://schemas.openxmlformats.org/drawingml/2006/main">
@@ -743,7 +743,7 @@
           </a:p>
           <a:p xmlns:a="http://schemas.openxmlformats.org/drawingml/2006/main">
             <a:r>
-              <a:t>https://github.com/joku-dev/devsecops-governance-framework/blob/689357712b8eaaa91968a6810c7f056adb6f6555/docs/operations/security/github-access-and-token-maintenance.md</a:t>
+              <a:t>https://github.com/joku-dev/devsecops-governance-framework/blob/4abe88294f299d7f801c74ff0161df234960c092/docs/operations/security/github-access-and-token-maintenance.md</a:t>
             </a:r>
           </a:p>
         </p:txBody>
@@ -823,7 +823,7 @@
           </a:p>
           <a:p xmlns:a="http://schemas.openxmlformats.org/drawingml/2006/main">
             <a:r>
-              <a:t>Quellstand: 689357712b8eaaa91968a6810c7f056adb6f6555</a:t>
+              <a:t>Quellstand: 4abe88294f299d7f801c74ff0161df234960c092</a:t>
             </a:r>
           </a:p>
           <a:p xmlns:a="http://schemas.openxmlformats.org/drawingml/2006/main">
@@ -833,7 +833,7 @@
           </a:p>
           <a:p xmlns:a="http://schemas.openxmlformats.org/drawingml/2006/main">
             <a:r>
-              <a:t>https://github.com/joku-dev/devsecops-governance-framework/blob/689357712b8eaaa91968a6810c7f056adb6f6555/docs/foundation/05_CURRENT_DIRECTION.md</a:t>
+              <a:t>https://github.com/joku-dev/devsecops-governance-framework/blob/4abe88294f299d7f801c74ff0161df234960c092/docs/foundation/05_CURRENT_DIRECTION.md</a:t>
             </a:r>
           </a:p>
           <a:p xmlns:a="http://schemas.openxmlformats.org/drawingml/2006/main">
@@ -848,7 +848,7 @@
           </a:p>
           <a:p xmlns:a="http://schemas.openxmlformats.org/drawingml/2006/main">
             <a:r>
-              <a:t>https://github.com/joku-dev/devsecops-governance-framework/blob/689357712b8eaaa91968a6810c7f056adb6f6555/docs/foundation/02_CONSTITUTION.md</a:t>
+              <a:t>https://github.com/joku-dev/devsecops-governance-framework/blob/4abe88294f299d7f801c74ff0161df234960c092/docs/foundation/02_CONSTITUTION.md</a:t>
             </a:r>
           </a:p>
           <a:p xmlns:a="http://schemas.openxmlformats.org/drawingml/2006/main">
@@ -863,7 +863,7 @@
           </a:p>
           <a:p xmlns:a="http://schemas.openxmlformats.org/drawingml/2006/main">
             <a:r>
-              <a:t>https://github.com/joku-dev/devsecops-governance-framework/blob/689357712b8eaaa91968a6810c7f056adb6f6555/docs/operations/guides/governance-repository-operations-handbook.md</a:t>
+              <a:t>https://github.com/joku-dev/devsecops-governance-framework/blob/4abe88294f299d7f801c74ff0161df234960c092/docs/operations/guides/governance-repository-operations-handbook.md</a:t>
             </a:r>
           </a:p>
           <a:p xmlns:a="http://schemas.openxmlformats.org/drawingml/2006/main">
@@ -878,7 +878,7 @@
           </a:p>
           <a:p xmlns:a="http://schemas.openxmlformats.org/drawingml/2006/main">
             <a:r>
-              <a:t>https://github.com/joku-dev/devsecops-governance-framework/blob/689357712b8eaaa91968a6810c7f056adb6f6555/generated/reports/blocking-readiness.json</a:t>
+              <a:t>https://github.com/joku-dev/devsecops-governance-framework/blob/4abe88294f299d7f801c74ff0161df234960c092/generated/reports/blocking-readiness.json</a:t>
             </a:r>
           </a:p>
         </p:txBody>
@@ -958,7 +958,7 @@
           </a:p>
           <a:p xmlns:a="http://schemas.openxmlformats.org/drawingml/2006/main">
             <a:r>
-              <a:t>Quellstand: 689357712b8eaaa91968a6810c7f056adb6f6555</a:t>
+              <a:t>Quellstand: 4abe88294f299d7f801c74ff0161df234960c092</a:t>
             </a:r>
           </a:p>
           <a:p xmlns:a="http://schemas.openxmlformats.org/drawingml/2006/main">
@@ -968,7 +968,7 @@
           </a:p>
           <a:p xmlns:a="http://schemas.openxmlformats.org/drawingml/2006/main">
             <a:r>
-              <a:t>https://github.com/joku-dev/devsecops-governance-framework/blob/689357712b8eaaa91968a6810c7f056adb6f6555/docs/operations/guides/governance-repository-operations-handbook.md</a:t>
+              <a:t>https://github.com/joku-dev/devsecops-governance-framework/blob/4abe88294f299d7f801c74ff0161df234960c092/docs/operations/guides/governance-repository-operations-handbook.md</a:t>
             </a:r>
           </a:p>
           <a:p xmlns:a="http://schemas.openxmlformats.org/drawingml/2006/main">
@@ -983,7 +983,7 @@
           </a:p>
           <a:p xmlns:a="http://schemas.openxmlformats.org/drawingml/2006/main">
             <a:r>
-              <a:t>https://github.com/joku-dev/devsecops-governance-framework/blob/689357712b8eaaa91968a6810c7f056adb6f6555/generated/reports/blocking-readiness.json</a:t>
+              <a:t>https://github.com/joku-dev/devsecops-governance-framework/blob/4abe88294f299d7f801c74ff0161df234960c092/generated/reports/blocking-readiness.json</a:t>
             </a:r>
           </a:p>
         </p:txBody>
@@ -1063,7 +1063,7 @@
           </a:p>
           <a:p xmlns:a="http://schemas.openxmlformats.org/drawingml/2006/main">
             <a:r>
-              <a:t>Quellstand: 689357712b8eaaa91968a6810c7f056adb6f6555</a:t>
+              <a:t>Quellstand: 4abe88294f299d7f801c74ff0161df234960c092</a:t>
             </a:r>
           </a:p>
           <a:p xmlns:a="http://schemas.openxmlformats.org/drawingml/2006/main">
@@ -1073,7 +1073,7 @@
           </a:p>
           <a:p xmlns:a="http://schemas.openxmlformats.org/drawingml/2006/main">
             <a:r>
-              <a:t>https://github.com/joku-dev/devsecops-governance-framework/blob/689357712b8eaaa91968a6810c7f056adb6f6555/docs/foundation/05_CURRENT_DIRECTION.md</a:t>
+              <a:t>https://github.com/joku-dev/devsecops-governance-framework/blob/4abe88294f299d7f801c74ff0161df234960c092/docs/foundation/05_CURRENT_DIRECTION.md</a:t>
             </a:r>
           </a:p>
           <a:p xmlns:a="http://schemas.openxmlformats.org/drawingml/2006/main">
@@ -1088,7 +1088,7 @@
           </a:p>
           <a:p xmlns:a="http://schemas.openxmlformats.org/drawingml/2006/main">
             <a:r>
-              <a:t>https://github.com/joku-dev/devsecops-governance-framework/blob/689357712b8eaaa91968a6810c7f056adb6f6555/docs/foundation/02_CONSTITUTION.md</a:t>
+              <a:t>https://github.com/joku-dev/devsecops-governance-framework/blob/4abe88294f299d7f801c74ff0161df234960c092/docs/foundation/02_CONSTITUTION.md</a:t>
             </a:r>
           </a:p>
           <a:p xmlns:a="http://schemas.openxmlformats.org/drawingml/2006/main">
@@ -1103,7 +1103,7 @@
           </a:p>
           <a:p xmlns:a="http://schemas.openxmlformats.org/drawingml/2006/main">
             <a:r>
-              <a:t>https://github.com/joku-dev/devsecops-governance-framework/blob/689357712b8eaaa91968a6810c7f056adb6f6555/docs/operations/evidence/governance-evidence-contract.md</a:t>
+              <a:t>https://github.com/joku-dev/devsecops-governance-framework/blob/4abe88294f299d7f801c74ff0161df234960c092/docs/operations/evidence/governance-evidence-contract.md</a:t>
             </a:r>
           </a:p>
         </p:txBody>
@@ -1183,7 +1183,7 @@
           </a:p>
           <a:p xmlns:a="http://schemas.openxmlformats.org/drawingml/2006/main">
             <a:r>
-              <a:t>Quellstand: 689357712b8eaaa91968a6810c7f056adb6f6555</a:t>
+              <a:t>Quellstand: 4abe88294f299d7f801c74ff0161df234960c092</a:t>
             </a:r>
           </a:p>
           <a:p xmlns:a="http://schemas.openxmlformats.org/drawingml/2006/main">
@@ -1193,7 +1193,7 @@
           </a:p>
           <a:p xmlns:a="http://schemas.openxmlformats.org/drawingml/2006/main">
             <a:r>
-              <a:t>https://github.com/joku-dev/devsecops-governance-framework/blob/689357712b8eaaa91968a6810c7f056adb6f6555/docs/operations/evidence/governance-evidence-contract.md</a:t>
+              <a:t>https://github.com/joku-dev/devsecops-governance-framework/blob/4abe88294f299d7f801c74ff0161df234960c092/docs/operations/evidence/governance-evidence-contract.md</a:t>
             </a:r>
           </a:p>
           <a:p xmlns:a="http://schemas.openxmlformats.org/drawingml/2006/main">
@@ -1208,7 +1208,7 @@
           </a:p>
           <a:p xmlns:a="http://schemas.openxmlformats.org/drawingml/2006/main">
             <a:r>
-              <a:t>https://github.com/joku-dev/devsecops-governance-framework/blob/689357712b8eaaa91968a6810c7f056adb6f6555/docs/operations/guides/governance-repository-operations-handbook.md</a:t>
+              <a:t>https://github.com/joku-dev/devsecops-governance-framework/blob/4abe88294f299d7f801c74ff0161df234960c092/docs/operations/guides/governance-repository-operations-handbook.md</a:t>
             </a:r>
           </a:p>
           <a:p xmlns:a="http://schemas.openxmlformats.org/drawingml/2006/main">
@@ -1223,7 +1223,7 @@
           </a:p>
           <a:p xmlns:a="http://schemas.openxmlformats.org/drawingml/2006/main">
             <a:r>
-              <a:t>https://github.com/joku-dev/devsecops-governance-framework/blob/689357712b8eaaa91968a6810c7f056adb6f6555/docs/operations/status/daily-governance-operations.md</a:t>
+              <a:t>https://github.com/joku-dev/devsecops-governance-framework/blob/4abe88294f299d7f801c74ff0161df234960c092/docs/operations/status/daily-governance-operations.md</a:t>
             </a:r>
           </a:p>
         </p:txBody>
@@ -1303,7 +1303,7 @@
           </a:p>
           <a:p xmlns:a="http://schemas.openxmlformats.org/drawingml/2006/main">
             <a:r>
-              <a:t>Quellstand: 689357712b8eaaa91968a6810c7f056adb6f6555</a:t>
+              <a:t>Quellstand: 4abe88294f299d7f801c74ff0161df234960c092</a:t>
             </a:r>
           </a:p>
           <a:p xmlns:a="http://schemas.openxmlformats.org/drawingml/2006/main">
@@ -1313,7 +1313,7 @@
           </a:p>
           <a:p xmlns:a="http://schemas.openxmlformats.org/drawingml/2006/main">
             <a:r>
-              <a:t>https://github.com/joku-dev/devsecops-governance-framework/blob/689357712b8eaaa91968a6810c7f056adb6f6555/docs/foundation/04_REFERENCE_ARCHITECTURE.md</a:t>
+              <a:t>https://github.com/joku-dev/devsecops-governance-framework/blob/4abe88294f299d7f801c74ff0161df234960c092/docs/foundation/04_REFERENCE_ARCHITECTURE.md</a:t>
             </a:r>
           </a:p>
           <a:p xmlns:a="http://schemas.openxmlformats.org/drawingml/2006/main">
@@ -1328,7 +1328,7 @@
           </a:p>
           <a:p xmlns:a="http://schemas.openxmlformats.org/drawingml/2006/main">
             <a:r>
-              <a:t>https://github.com/joku-dev/devsecops-governance-framework/blob/689357712b8eaaa91968a6810c7f056adb6f6555/docs/operations/evidence/governance-evidence-contract.md</a:t>
+              <a:t>https://github.com/joku-dev/devsecops-governance-framework/blob/4abe88294f299d7f801c74ff0161df234960c092/docs/operations/evidence/governance-evidence-contract.md</a:t>
             </a:r>
           </a:p>
           <a:p xmlns:a="http://schemas.openxmlformats.org/drawingml/2006/main">
@@ -1343,7 +1343,7 @@
           </a:p>
           <a:p xmlns:a="http://schemas.openxmlformats.org/drawingml/2006/main">
             <a:r>
-              <a:t>https://github.com/joku-dev/devsecops-governance-framework/blob/689357712b8eaaa91968a6810c7f056adb6f6555/docs/operations/evidence/governance-result-intake-and-viewer-usage.md</a:t>
+              <a:t>https://github.com/joku-dev/devsecops-governance-framework/blob/4abe88294f299d7f801c74ff0161df234960c092/docs/operations/evidence/governance-result-intake-and-viewer-usage.md</a:t>
             </a:r>
           </a:p>
         </p:txBody>
@@ -1423,7 +1423,7 @@
           </a:p>
           <a:p xmlns:a="http://schemas.openxmlformats.org/drawingml/2006/main">
             <a:r>
-              <a:t>Quellstand: 689357712b8eaaa91968a6810c7f056adb6f6555</a:t>
+              <a:t>Quellstand: 4abe88294f299d7f801c74ff0161df234960c092</a:t>
             </a:r>
           </a:p>
           <a:p xmlns:a="http://schemas.openxmlformats.org/drawingml/2006/main">
@@ -1433,7 +1433,7 @@
           </a:p>
           <a:p xmlns:a="http://schemas.openxmlformats.org/drawingml/2006/main">
             <a:r>
-              <a:t>https://github.com/joku-dev/devsecops-governance-framework/blob/689357712b8eaaa91968a6810c7f056adb6f6555/docs/foundation/02_CONSTITUTION.md</a:t>
+              <a:t>https://github.com/joku-dev/devsecops-governance-framework/blob/4abe88294f299d7f801c74ff0161df234960c092/docs/foundation/02_CONSTITUTION.md</a:t>
             </a:r>
           </a:p>
           <a:p xmlns:a="http://schemas.openxmlformats.org/drawingml/2006/main">
@@ -1448,7 +1448,7 @@
           </a:p>
           <a:p xmlns:a="http://schemas.openxmlformats.org/drawingml/2006/main">
             <a:r>
-              <a:t>https://github.com/joku-dev/devsecops-governance-framework/blob/689357712b8eaaa91968a6810c7f056adb6f6555/docs/operations/guides/governance-repository-operations-handbook.md</a:t>
+              <a:t>https://github.com/joku-dev/devsecops-governance-framework/blob/4abe88294f299d7f801c74ff0161df234960c092/docs/operations/guides/governance-repository-operations-handbook.md</a:t>
             </a:r>
           </a:p>
           <a:p xmlns:a="http://schemas.openxmlformats.org/drawingml/2006/main">
@@ -1463,7 +1463,7 @@
           </a:p>
           <a:p xmlns:a="http://schemas.openxmlformats.org/drawingml/2006/main">
             <a:r>
-              <a:t>https://github.com/joku-dev/devsecops-governance-framework/blob/689357712b8eaaa91968a6810c7f056adb6f6555/docs/operations/security/github-access-and-token-maintenance.md</a:t>
+              <a:t>https://github.com/joku-dev/devsecops-governance-framework/blob/4abe88294f299d7f801c74ff0161df234960c092/docs/operations/security/github-access-and-token-maintenance.md</a:t>
             </a:r>
           </a:p>
         </p:txBody>
@@ -1533,7 +1533,7 @@
           <a:lstStyle xmlns:a="http://schemas.openxmlformats.org/drawingml/2006/main"/>
           <a:p xmlns:a="http://schemas.openxmlformats.org/drawingml/2006/main">
             <a:r>
-              <a:t>Der Quellstand 6893577 enthält veröffentlichte Baselines, geschützte PR-Abläufe und tägliche Betriebsberichte. Die Hauptworkflows einschließlich Dokumentationsveröffentlichung waren an diesem Commit erfolgreich. Die Tabelle trennt Verfügbarkeit von Betriebserprobung.</a:t>
+              <a:t>Der Quellstand 4abe882 enthält veröffentlichte Baselines, geschützte PR-Abläufe und tägliche Betriebsberichte. Governance CI, CodeQL, Self-Security und Dokumentationsveröffentlichung waren erfolgreich. Neue reale Ergebnisse für drei Consumer sind angenommen. Die Tabelle trennt technische Verfügbarkeit von längerfristiger Betriebserprobung.</a:t>
             </a:r>
           </a:p>
           <a:p xmlns:a="http://schemas.openxmlformats.org/drawingml/2006/main">
@@ -1543,7 +1543,7 @@
           </a:p>
           <a:p xmlns:a="http://schemas.openxmlformats.org/drawingml/2006/main">
             <a:r>
-              <a:t>Quellstand: 689357712b8eaaa91968a6810c7f056adb6f6555</a:t>
+              <a:t>Quellstand: 4abe88294f299d7f801c74ff0161df234960c092</a:t>
             </a:r>
           </a:p>
           <a:p xmlns:a="http://schemas.openxmlformats.org/drawingml/2006/main">
@@ -1553,7 +1553,7 @@
           </a:p>
           <a:p xmlns:a="http://schemas.openxmlformats.org/drawingml/2006/main">
             <a:r>
-              <a:t>https://github.com/joku-dev/devsecops-governance-framework/blob/689357712b8eaaa91968a6810c7f056adb6f6555/docs/operations/guides/governance-repository-operations-handbook.md</a:t>
+              <a:t>https://github.com/joku-dev/devsecops-governance-framework/blob/4abe88294f299d7f801c74ff0161df234960c092/docs/operations/guides/governance-repository-operations-handbook.md</a:t>
             </a:r>
           </a:p>
           <a:p xmlns:a="http://schemas.openxmlformats.org/drawingml/2006/main">
@@ -1563,12 +1563,12 @@
           </a:p>
           <a:p xmlns:a="http://schemas.openxmlformats.org/drawingml/2006/main">
             <a:r>
-              <a:t>[8] Stand und datierte Referenznachweise</a:t>
-            </a:r>
-          </a:p>
-          <a:p xmlns:a="http://schemas.openxmlformats.org/drawingml/2006/main">
-            <a:r>
-              <a:t>https://github.com/joku-dev/devsecops-governance-framework/blob/689357712b8eaaa91968a6810c7f056adb6f6555/docs/operations/status/current-governance-platform-state.md</a:t>
+              <a:t>[8] Angenommene DevSecOps-Ergebnisse und Trust-Kontext</a:t>
+            </a:r>
+          </a:p>
+          <a:p xmlns:a="http://schemas.openxmlformats.org/drawingml/2006/main">
+            <a:r>
+              <a:t>https://github.com/joku-dev/devsecops-governance-framework/blob/4abe88294f299d7f801c74ff0161df234960c092/status/repository-results-index.json</a:t>
             </a:r>
           </a:p>
           <a:p xmlns:a="http://schemas.openxmlformats.org/drawingml/2006/main">
@@ -1583,7 +1583,7 @@
           </a:p>
           <a:p xmlns:a="http://schemas.openxmlformats.org/drawingml/2006/main">
             <a:r>
-              <a:t>https://github.com/joku-dev/devsecops-governance-framework/blob/689357712b8eaaa91968a6810c7f056adb6f6555/docs/operations/status/daily-governance-operations.md</a:t>
+              <a:t>https://github.com/joku-dev/devsecops-governance-framework/blob/4abe88294f299d7f801c74ff0161df234960c092/docs/operations/status/daily-governance-operations.md</a:t>
             </a:r>
           </a:p>
           <a:p xmlns:a="http://schemas.openxmlformats.org/drawingml/2006/main">
@@ -1598,7 +1598,7 @@
           </a:p>
           <a:p xmlns:a="http://schemas.openxmlformats.org/drawingml/2006/main">
             <a:r>
-              <a:t>https://github.com/joku-dev/devsecops-governance-framework/actions/runs/34339545699</a:t>
+              <a:t>https://github.com/joku-dev/devsecops-governance-framework/actions/runs/34611502655</a:t>
             </a:r>
           </a:p>
           <a:p xmlns:a="http://schemas.openxmlformats.org/drawingml/2006/main">
@@ -1613,7 +1613,7 @@
           </a:p>
           <a:p xmlns:a="http://schemas.openxmlformats.org/drawingml/2006/main">
             <a:r>
-              <a:t>https://github.com/joku-dev/devsecops-governance-framework/actions/runs/34339545693</a:t>
+              <a:t>https://github.com/joku-dev/devsecops-governance-framework/actions/runs/34611502609</a:t>
             </a:r>
           </a:p>
           <a:p xmlns:a="http://schemas.openxmlformats.org/drawingml/2006/main">
@@ -1628,7 +1628,7 @@
           </a:p>
           <a:p xmlns:a="http://schemas.openxmlformats.org/drawingml/2006/main">
             <a:r>
-              <a:t>https://github.com/joku-dev/devsecops-governance-framework/actions/runs/34339545772</a:t>
+              <a:t>https://github.com/joku-dev/devsecops-governance-framework/actions/runs/34611502982</a:t>
             </a:r>
           </a:p>
           <a:p xmlns:a="http://schemas.openxmlformats.org/drawingml/2006/main">
@@ -1643,7 +1643,22 @@
           </a:p>
           <a:p xmlns:a="http://schemas.openxmlformats.org/drawingml/2006/main">
             <a:r>
-              <a:t>https://github.com/joku-dev/devsecops-governance-framework/actions/runs/34339545695</a:t>
+              <a:t>https://github.com/joku-dev/devsecops-governance-framework/actions/runs/34611502768</a:t>
+            </a:r>
+          </a:p>
+          <a:p xmlns:a="http://schemas.openxmlformats.org/drawingml/2006/main">
+            <a:r>
+              <a:t/>
+            </a:r>
+          </a:p>
+          <a:p xmlns:a="http://schemas.openxmlformats.org/drawingml/2006/main">
+            <a:r>
+              <a:t>[18] Portfolio am 11. September 2026</a:t>
+            </a:r>
+          </a:p>
+          <a:p xmlns:a="http://schemas.openxmlformats.org/drawingml/2006/main">
+            <a:r>
+              <a:t>https://github.com/joku-dev/devsecops-governance-framework/blob/4abe88294f299d7f801c74ff0161df234960c092/generated/reports/portfolio-onboarding-status.json</a:t>
             </a:r>
           </a:p>
         </p:txBody>
@@ -1713,7 +1728,7 @@
           <a:lstStyle xmlns:a="http://schemas.openxmlformats.org/drawingml/2006/main"/>
           <a:p xmlns:a="http://schemas.openxmlformats.org/drawingml/2006/main">
             <a:r>
-              <a:t>Historische Läufe: DevSecOps 29415015878, Architektur 29415015294. Beide beziehen sich auf Commit 716c3cda4fa5cef7504ca7b3263f0cd1697b6e6c. Die Juli-Ergebnisse belegen die damalige Integration. Eine erneute Aufnahme im September macht sie nicht aktuell. Es liegt dadurch keine neue Bewertung der Anwendung vor.</a:t>
+              <a:t>Neue main-push-Läufe: DevSecOps 34602002201, Architektur 34602001140, Consumer-Commit 6976bb2af2b9d47d2934273c444b6c9b62a81ea2. 16 von 16 anwendbaren Controls bestehen, 30 weitere sind nicht anwendbar. Architektur: vier von vier Gates, null Befunde. Der separate DevSecOps-Replay-Check bleibt fehlgeschlagen. Die Factory meldet einen Branchschutz-Befund, der neutrale Demo-Consumer 25 Architektur-Befunde. Dessen DevSecOps-pass ist ein einzelnes zusammengefasstes Baseline-Gate. Das Portfolio enthält drei Consumer ohne veraltete oder fehlende Ergebnisse im Beobachtungszeitpunkt. Diese Nachweise sind keine Produktionsfreigabe.</a:t>
             </a:r>
           </a:p>
           <a:p xmlns:a="http://schemas.openxmlformats.org/drawingml/2006/main">
@@ -1723,17 +1738,47 @@
           </a:p>
           <a:p xmlns:a="http://schemas.openxmlformats.org/drawingml/2006/main">
             <a:r>
-              <a:t>Quellstand: 689357712b8eaaa91968a6810c7f056adb6f6555</a:t>
-            </a:r>
-          </a:p>
-          <a:p xmlns:a="http://schemas.openxmlformats.org/drawingml/2006/main">
-            <a:r>
-              <a:t>[8] Stand und datierte Referenznachweise</a:t>
-            </a:r>
-          </a:p>
-          <a:p xmlns:a="http://schemas.openxmlformats.org/drawingml/2006/main">
-            <a:r>
-              <a:t>https://github.com/joku-dev/devsecops-governance-framework/blob/689357712b8eaaa91968a6810c7f056adb6f6555/docs/operations/status/current-governance-platform-state.md</a:t>
+              <a:t>Quellstand: 4abe88294f299d7f801c74ff0161df234960c092</a:t>
+            </a:r>
+          </a:p>
+          <a:p xmlns:a="http://schemas.openxmlformats.org/drawingml/2006/main">
+            <a:r>
+              <a:t>[8] Angenommene DevSecOps-Ergebnisse und Trust-Kontext</a:t>
+            </a:r>
+          </a:p>
+          <a:p xmlns:a="http://schemas.openxmlformats.org/drawingml/2006/main">
+            <a:r>
+              <a:t>https://github.com/joku-dev/devsecops-governance-framework/blob/4abe88294f299d7f801c74ff0161df234960c092/status/repository-results-index.json</a:t>
+            </a:r>
+          </a:p>
+          <a:p xmlns:a="http://schemas.openxmlformats.org/drawingml/2006/main">
+            <a:r>
+              <a:t/>
+            </a:r>
+          </a:p>
+          <a:p xmlns:a="http://schemas.openxmlformats.org/drawingml/2006/main">
+            <a:r>
+              <a:t>[17] Angenommene Architektur-Ergebnisse</a:t>
+            </a:r>
+          </a:p>
+          <a:p xmlns:a="http://schemas.openxmlformats.org/drawingml/2006/main">
+            <a:r>
+              <a:t>https://github.com/joku-dev/devsecops-governance-framework/blob/4abe88294f299d7f801c74ff0161df234960c092/status/architecture-results-index.json</a:t>
+            </a:r>
+          </a:p>
+          <a:p xmlns:a="http://schemas.openxmlformats.org/drawingml/2006/main">
+            <a:r>
+              <a:t/>
+            </a:r>
+          </a:p>
+          <a:p xmlns:a="http://schemas.openxmlformats.org/drawingml/2006/main">
+            <a:r>
+              <a:t>[18] Portfolio am 11. September 2026</a:t>
+            </a:r>
+          </a:p>
+          <a:p xmlns:a="http://schemas.openxmlformats.org/drawingml/2006/main">
+            <a:r>
+              <a:t>https://github.com/joku-dev/devsecops-governance-framework/blob/4abe88294f299d7f801c74ff0161df234960c092/generated/reports/portfolio-onboarding-status.json</a:t>
             </a:r>
           </a:p>
         </p:txBody>
@@ -1803,7 +1848,7 @@
           <a:lstStyle xmlns:a="http://schemas.openxmlformats.org/drawingml/2006/main"/>
           <a:p xmlns:a="http://schemas.openxmlformats.org/drawingml/2006/main">
             <a:r>
-              <a:t>Bewertungsstand: generated_at 2026-09-09T08:18:36Z, drei Integrationen, null ready, drei not_ready und eine bereits blockierende Integration unterhalb der neuen Anforderungen. Der Bestandsmodus ist keine Freigabe für neues Blocking. Ein erfolgreicher Workflow allein genügt nicht.</a:t>
+              <a:t>Bewertungsstand: generated_at 2026-09-11T14:34:14Z, drei Integrationen, null ready, drei not_ready und eine bereits blockierende Integration unterhalb der neuen Anforderungen. Aktuelle Typed Evidence des neutralen Consumers ist angenommen, weitere Trust-, Architektur- und Betriebskriterien bleiben offen. Der Bestandsmodus ist keine Freigabe für neues Blocking. Ein erfolgreicher Workflow allein genügt nicht.</a:t>
             </a:r>
           </a:p>
           <a:p xmlns:a="http://schemas.openxmlformats.org/drawingml/2006/main">
@@ -1813,7 +1858,7 @@
           </a:p>
           <a:p xmlns:a="http://schemas.openxmlformats.org/drawingml/2006/main">
             <a:r>
-              <a:t>Quellstand: 689357712b8eaaa91968a6810c7f056adb6f6555</a:t>
+              <a:t>Quellstand: 4abe88294f299d7f801c74ff0161df234960c092</a:t>
             </a:r>
           </a:p>
           <a:p xmlns:a="http://schemas.openxmlformats.org/drawingml/2006/main">
@@ -1823,7 +1868,7 @@
           </a:p>
           <a:p xmlns:a="http://schemas.openxmlformats.org/drawingml/2006/main">
             <a:r>
-              <a:t>https://github.com/joku-dev/devsecops-governance-framework/blob/689357712b8eaaa91968a6810c7f056adb6f6555/generated/reports/blocking-readiness.json</a:t>
+              <a:t>https://github.com/joku-dev/devsecops-governance-framework/blob/4abe88294f299d7f801c74ff0161df234960c092/generated/reports/blocking-readiness.json</a:t>
             </a:r>
           </a:p>
           <a:p xmlns:a="http://schemas.openxmlformats.org/drawingml/2006/main">
@@ -1838,7 +1883,7 @@
           </a:p>
           <a:p xmlns:a="http://schemas.openxmlformats.org/drawingml/2006/main">
             <a:r>
-              <a:t>https://github.com/joku-dev/devsecops-governance-framework/blob/689357712b8eaaa91968a6810c7f056adb6f6555/docs/operations/status/blocking-mode-alignment.md</a:t>
+              <a:t>https://github.com/joku-dev/devsecops-governance-framework/blob/4abe88294f299d7f801c74ff0161df234960c092/docs/operations/status/blocking-mode-alignment.md</a:t>
             </a:r>
           </a:p>
         </p:txBody>
@@ -1906,7 +1951,7 @@
   </p:cSld>
   <p:clrMap bg1="lt1" tx1="dk1" bg2="lt2" tx2="dk2" accent1="accent1" accent2="accent2" accent3="accent3" accent4="accent4" accent5="accent5" accent6="accent6" hlink="hlink" folHlink="folHlink"/>
   <p:sldLayoutIdLst>
-    <p:sldLayoutId xmlns:r="http://schemas.openxmlformats.org/officeDocument/2006/relationships" id="2147483649" r:id="R41f0abd6f21d40e7"/>
+    <p:sldLayoutId xmlns:r="http://schemas.openxmlformats.org/officeDocument/2006/relationships" id="2147483649" r:id="Rd4cb74309a284ff8"/>
   </p:sldLayoutIdLst>
   <p:txStyles>
     <p:titleStyle>
@@ -2457,7 +2502,7 @@
           <p:cNvPr id="4" name="">
             <a:extLst xmlns:a="http://schemas.openxmlformats.org/drawingml/2006/main">
               <a:ext uri="{FF2B5EF4-FFF2-40B4-BE49-F238E27FC236}">
-                <a16:creationId xmlns:a16="http://schemas.microsoft.com/office/drawing/2014/main" id="{A94D68C7-E69C-4C84-AC28-7A6FA81D75DA}"/>
+                <a16:creationId xmlns:a16="http://schemas.microsoft.com/office/drawing/2014/main" id="{FD7186B4-A4D3-48EB-BC0E-84D29AC32C3C}"/>
               </a:ext>
             </a:extLst>
           </p:cNvPr>
@@ -2514,7 +2559,7 @@
           <p:cNvPr id="2" name="">
             <a:extLst xmlns:a="http://schemas.openxmlformats.org/drawingml/2006/main">
               <a:ext uri="{FF2B5EF4-FFF2-40B4-BE49-F238E27FC236}">
-                <a16:creationId xmlns:a16="http://schemas.microsoft.com/office/drawing/2014/main" id="{E17E9582-3FA4-4D30-AA0D-1195BD655E98}"/>
+                <a16:creationId xmlns:a16="http://schemas.microsoft.com/office/drawing/2014/main" id="{1952CF46-637C-451A-9787-6F3FF35F5F14}"/>
               </a:ext>
             </a:extLst>
           </p:cNvPr>
@@ -2571,7 +2616,7 @@
           <p:cNvPr id="3" name="">
             <a:extLst xmlns:a="http://schemas.openxmlformats.org/drawingml/2006/main">
               <a:ext uri="{FF2B5EF4-FFF2-40B4-BE49-F238E27FC236}">
-                <a16:creationId xmlns:a16="http://schemas.microsoft.com/office/drawing/2014/main" id="{B335D6D0-149E-4CEF-BC7F-A0D61CE92239}"/>
+                <a16:creationId xmlns:a16="http://schemas.microsoft.com/office/drawing/2014/main" id="{B9EA66EE-CCC9-4A4D-8329-8B746FF31B31}"/>
               </a:ext>
             </a:extLst>
           </p:cNvPr>
@@ -2618,7 +2663,7 @@
                 <a:ea typeface="Arial"/>
                 <a:cs typeface="Arial"/>
               </a:rPr>
-              <a:t>Stand 9. September 2026</a:t>
+              <a:t>Stand 11. September 2026</a:t>
             </a:r>
           </a:p>
         </p:txBody>
@@ -2626,7 +2671,7 @@
     </p:spTree>
     <p:extLst>
       <p:ext uri="{BB962C8B-B14F-4D97-AF65-F5344CB8AC3E}">
-        <p14:creationId xmlns:p14="http://schemas.microsoft.com/office/powerpoint/2010/main" val="1680710409"/>
+        <p14:creationId xmlns:p14="http://schemas.microsoft.com/office/powerpoint/2010/main" val="1507897422"/>
       </p:ext>
     </p:extLst>
   </p:cSld>
@@ -2657,7 +2702,7 @@
           <p:cNvPr id="5" name="">
             <a:extLst xmlns:a="http://schemas.openxmlformats.org/drawingml/2006/main">
               <a:ext uri="{FF2B5EF4-FFF2-40B4-BE49-F238E27FC236}">
-                <a16:creationId xmlns:a16="http://schemas.microsoft.com/office/drawing/2014/main" id="{B4581F0F-6154-49CE-BDC2-0AF13FB1DCC8}"/>
+                <a16:creationId xmlns:a16="http://schemas.microsoft.com/office/drawing/2014/main" id="{19BB5D69-9EF4-46FD-8602-F7C335761F64}"/>
               </a:ext>
             </a:extLst>
           </p:cNvPr>
@@ -2714,7 +2759,7 @@
           <p:cNvPr id="2" name="">
             <a:extLst xmlns:a="http://schemas.openxmlformats.org/drawingml/2006/main">
               <a:ext uri="{FF2B5EF4-FFF2-40B4-BE49-F238E27FC236}">
-                <a16:creationId xmlns:a16="http://schemas.microsoft.com/office/drawing/2014/main" id="{82F01C7E-32C3-4300-A47C-9E46C9297586}"/>
+                <a16:creationId xmlns:a16="http://schemas.microsoft.com/office/drawing/2014/main" id="{5AEE9972-474E-4E34-9883-7E44821810C5}"/>
               </a:ext>
             </a:extLst>
           </p:cNvPr>
@@ -3063,7 +3108,7 @@
           <p:cNvPr id="4" name="">
             <a:extLst xmlns:a="http://schemas.openxmlformats.org/drawingml/2006/main">
               <a:ext uri="{FF2B5EF4-FFF2-40B4-BE49-F238E27FC236}">
-                <a16:creationId xmlns:a16="http://schemas.microsoft.com/office/drawing/2014/main" id="{09B04F23-789F-45FD-973E-A77EB45E5514}"/>
+                <a16:creationId xmlns:a16="http://schemas.microsoft.com/office/drawing/2014/main" id="{BF5E20F9-CB6A-4BA8-8A8F-0D3BB166004F}"/>
               </a:ext>
             </a:extLst>
           </p:cNvPr>
@@ -3110,7 +3155,7 @@
                 <a:ea typeface="Arial"/>
                 <a:cs typeface="Arial"/>
               </a:rPr>
-              <a:t>9. September 2026     10 / 12</a:t>
+              <a:t>11. September 2026     10 / 12</a:t>
             </a:r>
           </a:p>
         </p:txBody>
@@ -3118,7 +3163,7 @@
     </p:spTree>
     <p:extLst>
       <p:ext uri="{BB962C8B-B14F-4D97-AF65-F5344CB8AC3E}">
-        <p14:creationId xmlns:p14="http://schemas.microsoft.com/office/powerpoint/2010/main" val="216265332"/>
+        <p14:creationId xmlns:p14="http://schemas.microsoft.com/office/powerpoint/2010/main" val="456827621"/>
       </p:ext>
     </p:extLst>
   </p:cSld>
@@ -3149,7 +3194,7 @@
           <p:cNvPr id="10" name="">
             <a:extLst xmlns:a="http://schemas.openxmlformats.org/drawingml/2006/main">
               <a:ext uri="{FF2B5EF4-FFF2-40B4-BE49-F238E27FC236}">
-                <a16:creationId xmlns:a16="http://schemas.microsoft.com/office/drawing/2014/main" id="{40C156DA-36AB-4E9A-A604-CDE2A325376C}"/>
+                <a16:creationId xmlns:a16="http://schemas.microsoft.com/office/drawing/2014/main" id="{BDED7530-1ECD-412D-86C7-EC95D3014C16}"/>
               </a:ext>
             </a:extLst>
           </p:cNvPr>
@@ -3206,7 +3251,7 @@
           <p:cNvPr id="2" name="">
             <a:extLst xmlns:a="http://schemas.openxmlformats.org/drawingml/2006/main">
               <a:ext uri="{FF2B5EF4-FFF2-40B4-BE49-F238E27FC236}">
-                <a16:creationId xmlns:a16="http://schemas.microsoft.com/office/drawing/2014/main" id="{780BF3D8-C4FC-4067-BF05-BA43E14B4EB0}"/>
+                <a16:creationId xmlns:a16="http://schemas.microsoft.com/office/drawing/2014/main" id="{0CE508AB-522B-4CBA-8752-F3BAB39AAE04}"/>
               </a:ext>
             </a:extLst>
           </p:cNvPr>
@@ -3263,7 +3308,7 @@
           <p:cNvPr id="3" name="">
             <a:extLst xmlns:a="http://schemas.openxmlformats.org/drawingml/2006/main">
               <a:ext uri="{FF2B5EF4-FFF2-40B4-BE49-F238E27FC236}">
-                <a16:creationId xmlns:a16="http://schemas.microsoft.com/office/drawing/2014/main" id="{C4B9B110-78A2-4AB1-99D2-FCE0B9AE9A09}"/>
+                <a16:creationId xmlns:a16="http://schemas.microsoft.com/office/drawing/2014/main" id="{D722114C-9849-4176-AB8E-7A2F376AEC01}"/>
               </a:ext>
             </a:extLst>
           </p:cNvPr>
@@ -3320,7 +3365,7 @@
           <p:cNvPr id="4" name="">
             <a:extLst xmlns:a="http://schemas.openxmlformats.org/drawingml/2006/main">
               <a:ext uri="{FF2B5EF4-FFF2-40B4-BE49-F238E27FC236}">
-                <a16:creationId xmlns:a16="http://schemas.microsoft.com/office/drawing/2014/main" id="{17769E4C-16F2-44D7-ABB4-C838A2808431}"/>
+                <a16:creationId xmlns:a16="http://schemas.microsoft.com/office/drawing/2014/main" id="{1B85A965-8DF0-4850-8868-2AFEB627C6F1}"/>
               </a:ext>
             </a:extLst>
           </p:cNvPr>
@@ -3377,7 +3422,7 @@
           <p:cNvPr id="5" name="">
             <a:extLst xmlns:a="http://schemas.openxmlformats.org/drawingml/2006/main">
               <a:ext uri="{FF2B5EF4-FFF2-40B4-BE49-F238E27FC236}">
-                <a16:creationId xmlns:a16="http://schemas.microsoft.com/office/drawing/2014/main" id="{DBE11D21-2385-44F9-9776-07C21169E569}"/>
+                <a16:creationId xmlns:a16="http://schemas.microsoft.com/office/drawing/2014/main" id="{8B735692-7A3A-41C7-B60F-1A1C0858484A}"/>
               </a:ext>
             </a:extLst>
           </p:cNvPr>
@@ -3434,7 +3479,7 @@
           <p:cNvPr id="6" name="">
             <a:extLst xmlns:a="http://schemas.openxmlformats.org/drawingml/2006/main">
               <a:ext uri="{FF2B5EF4-FFF2-40B4-BE49-F238E27FC236}">
-                <a16:creationId xmlns:a16="http://schemas.microsoft.com/office/drawing/2014/main" id="{8763368A-6413-4885-B590-4A082A5A32F4}"/>
+                <a16:creationId xmlns:a16="http://schemas.microsoft.com/office/drawing/2014/main" id="{6E893D09-70CC-4F87-AB05-F01F57941E6D}"/>
               </a:ext>
             </a:extLst>
           </p:cNvPr>
@@ -3491,7 +3536,7 @@
           <p:cNvPr id="7" name="">
             <a:extLst xmlns:a="http://schemas.openxmlformats.org/drawingml/2006/main">
               <a:ext uri="{FF2B5EF4-FFF2-40B4-BE49-F238E27FC236}">
-                <a16:creationId xmlns:a16="http://schemas.microsoft.com/office/drawing/2014/main" id="{FF58A051-1A11-4D26-B494-210B1B7BE456}"/>
+                <a16:creationId xmlns:a16="http://schemas.microsoft.com/office/drawing/2014/main" id="{C850DB90-6BA3-4414-AAEE-F786E1302EC5}"/>
               </a:ext>
             </a:extLst>
           </p:cNvPr>
@@ -3548,7 +3593,7 @@
           <p:cNvPr id="8" name="">
             <a:extLst xmlns:a="http://schemas.openxmlformats.org/drawingml/2006/main">
               <a:ext uri="{FF2B5EF4-FFF2-40B4-BE49-F238E27FC236}">
-                <a16:creationId xmlns:a16="http://schemas.microsoft.com/office/drawing/2014/main" id="{E27194E8-63AC-4BD0-92CC-23A3A1D64131}"/>
+                <a16:creationId xmlns:a16="http://schemas.microsoft.com/office/drawing/2014/main" id="{E9104884-22A0-4009-BA7B-B1F9ACB72BB7}"/>
               </a:ext>
             </a:extLst>
           </p:cNvPr>
@@ -3605,7 +3650,7 @@
           <p:cNvPr id="9" name="">
             <a:extLst xmlns:a="http://schemas.openxmlformats.org/drawingml/2006/main">
               <a:ext uri="{FF2B5EF4-FFF2-40B4-BE49-F238E27FC236}">
-                <a16:creationId xmlns:a16="http://schemas.microsoft.com/office/drawing/2014/main" id="{BDB2FC47-CB52-4CA6-9D55-ABE7DA87CEA2}"/>
+                <a16:creationId xmlns:a16="http://schemas.microsoft.com/office/drawing/2014/main" id="{19C79E85-8570-482E-A23D-A43649226ACD}"/>
               </a:ext>
             </a:extLst>
           </p:cNvPr>
@@ -3652,7 +3697,7 @@
                 <a:ea typeface="Arial"/>
                 <a:cs typeface="Arial"/>
               </a:rPr>
-              <a:t>9. September 2026     11 / 12</a:t>
+              <a:t>11. September 2026     11 / 12</a:t>
             </a:r>
           </a:p>
         </p:txBody>
@@ -3660,7 +3705,7 @@
     </p:spTree>
     <p:extLst>
       <p:ext uri="{BB962C8B-B14F-4D97-AF65-F5344CB8AC3E}">
-        <p14:creationId xmlns:p14="http://schemas.microsoft.com/office/powerpoint/2010/main" val="893543115"/>
+        <p14:creationId xmlns:p14="http://schemas.microsoft.com/office/powerpoint/2010/main" val="1198009076"/>
       </p:ext>
     </p:extLst>
   </p:cSld>
@@ -3691,7 +3736,7 @@
           <p:cNvPr id="10" name="">
             <a:extLst xmlns:a="http://schemas.openxmlformats.org/drawingml/2006/main">
               <a:ext uri="{FF2B5EF4-FFF2-40B4-BE49-F238E27FC236}">
-                <a16:creationId xmlns:a16="http://schemas.microsoft.com/office/drawing/2014/main" id="{C972781C-A1A1-4A4C-9F5E-B25ACA3F2B07}"/>
+                <a16:creationId xmlns:a16="http://schemas.microsoft.com/office/drawing/2014/main" id="{79F389A7-0FCB-4367-89CC-366848DC8A26}"/>
               </a:ext>
             </a:extLst>
           </p:cNvPr>
@@ -3748,7 +3793,7 @@
           <p:cNvPr id="2" name="">
             <a:extLst xmlns:a="http://schemas.openxmlformats.org/drawingml/2006/main">
               <a:ext uri="{FF2B5EF4-FFF2-40B4-BE49-F238E27FC236}">
-                <a16:creationId xmlns:a16="http://schemas.microsoft.com/office/drawing/2014/main" id="{C5F76C7A-A8B6-4135-86F3-0379FEAB0E2A}"/>
+                <a16:creationId xmlns:a16="http://schemas.microsoft.com/office/drawing/2014/main" id="{1216B7AD-9616-4929-A785-301BA8D9EEA0}"/>
               </a:ext>
             </a:extLst>
           </p:cNvPr>
@@ -3805,7 +3850,7 @@
           <p:cNvPr id="3" name="">
             <a:extLst xmlns:a="http://schemas.openxmlformats.org/drawingml/2006/main">
               <a:ext uri="{FF2B5EF4-FFF2-40B4-BE49-F238E27FC236}">
-                <a16:creationId xmlns:a16="http://schemas.microsoft.com/office/drawing/2014/main" id="{02A478E4-EBB0-4FC0-BBB5-FBD81A791E63}"/>
+                <a16:creationId xmlns:a16="http://schemas.microsoft.com/office/drawing/2014/main" id="{82898AF7-1B6A-49EF-8515-350BDD227993}"/>
               </a:ext>
             </a:extLst>
           </p:cNvPr>
@@ -3862,7 +3907,7 @@
           <p:cNvPr id="4" name="">
             <a:extLst xmlns:a="http://schemas.openxmlformats.org/drawingml/2006/main">
               <a:ext uri="{FF2B5EF4-FFF2-40B4-BE49-F238E27FC236}">
-                <a16:creationId xmlns:a16="http://schemas.microsoft.com/office/drawing/2014/main" id="{E43A952D-1754-44C4-A5A1-69640DB14539}"/>
+                <a16:creationId xmlns:a16="http://schemas.microsoft.com/office/drawing/2014/main" id="{B01BF627-B5CA-478D-8DAE-461B758EACEE}"/>
               </a:ext>
             </a:extLst>
           </p:cNvPr>
@@ -3919,7 +3964,7 @@
           <p:cNvPr id="5" name="">
             <a:extLst xmlns:a="http://schemas.openxmlformats.org/drawingml/2006/main">
               <a:ext uri="{FF2B5EF4-FFF2-40B4-BE49-F238E27FC236}">
-                <a16:creationId xmlns:a16="http://schemas.microsoft.com/office/drawing/2014/main" id="{AD562EF2-EDA3-47F4-88A0-69BFB6E552C5}"/>
+                <a16:creationId xmlns:a16="http://schemas.microsoft.com/office/drawing/2014/main" id="{D766675E-7F72-4B61-B914-1CBD09E3AB3D}"/>
               </a:ext>
             </a:extLst>
           </p:cNvPr>
@@ -3976,7 +4021,7 @@
           <p:cNvPr id="6" name="">
             <a:extLst xmlns:a="http://schemas.openxmlformats.org/drawingml/2006/main">
               <a:ext uri="{FF2B5EF4-FFF2-40B4-BE49-F238E27FC236}">
-                <a16:creationId xmlns:a16="http://schemas.microsoft.com/office/drawing/2014/main" id="{8DA4543A-A8E0-467B-A4B7-6B129093AEBB}"/>
+                <a16:creationId xmlns:a16="http://schemas.microsoft.com/office/drawing/2014/main" id="{C7C12F15-0A96-4296-ADA7-BD473F4D231E}"/>
               </a:ext>
             </a:extLst>
           </p:cNvPr>
@@ -4033,7 +4078,7 @@
           <p:cNvPr id="7" name="">
             <a:extLst xmlns:a="http://schemas.openxmlformats.org/drawingml/2006/main">
               <a:ext uri="{FF2B5EF4-FFF2-40B4-BE49-F238E27FC236}">
-                <a16:creationId xmlns:a16="http://schemas.microsoft.com/office/drawing/2014/main" id="{C5C34CF6-D929-4695-8029-7EA99CC203BA}"/>
+                <a16:creationId xmlns:a16="http://schemas.microsoft.com/office/drawing/2014/main" id="{212E29A3-7272-42D0-8665-53AA9B784C01}"/>
               </a:ext>
             </a:extLst>
           </p:cNvPr>
@@ -4090,7 +4135,7 @@
           <p:cNvPr id="8" name="">
             <a:extLst xmlns:a="http://schemas.openxmlformats.org/drawingml/2006/main">
               <a:ext uri="{FF2B5EF4-FFF2-40B4-BE49-F238E27FC236}">
-                <a16:creationId xmlns:a16="http://schemas.microsoft.com/office/drawing/2014/main" id="{C12E3A91-F9B9-44CE-837D-3B40A1B880D5}"/>
+                <a16:creationId xmlns:a16="http://schemas.microsoft.com/office/drawing/2014/main" id="{035E77FC-5E1F-440B-9E7D-27B9843CC45D}"/>
               </a:ext>
             </a:extLst>
           </p:cNvPr>
@@ -4147,7 +4192,7 @@
           <p:cNvPr id="9" name="">
             <a:extLst xmlns:a="http://schemas.openxmlformats.org/drawingml/2006/main">
               <a:ext uri="{FF2B5EF4-FFF2-40B4-BE49-F238E27FC236}">
-                <a16:creationId xmlns:a16="http://schemas.microsoft.com/office/drawing/2014/main" id="{A8A138A3-87DB-4C69-B506-9E23D464092B}"/>
+                <a16:creationId xmlns:a16="http://schemas.microsoft.com/office/drawing/2014/main" id="{1DAACBE6-4026-46B9-991E-40FBCA75D549}"/>
               </a:ext>
             </a:extLst>
           </p:cNvPr>
@@ -4194,7 +4239,7 @@
                 <a:ea typeface="Arial"/>
                 <a:cs typeface="Arial"/>
               </a:rPr>
-              <a:t>9. September 2026     12 / 12</a:t>
+              <a:t>11. September 2026     12 / 12</a:t>
             </a:r>
           </a:p>
         </p:txBody>
@@ -4202,7 +4247,7 @@
     </p:spTree>
     <p:extLst>
       <p:ext uri="{BB962C8B-B14F-4D97-AF65-F5344CB8AC3E}">
-        <p14:creationId xmlns:p14="http://schemas.microsoft.com/office/powerpoint/2010/main" val="333440852"/>
+        <p14:creationId xmlns:p14="http://schemas.microsoft.com/office/powerpoint/2010/main" val="246691749"/>
       </p:ext>
     </p:extLst>
   </p:cSld>
@@ -4233,7 +4278,7 @@
           <p:cNvPr id="10" name="">
             <a:extLst xmlns:a="http://schemas.openxmlformats.org/drawingml/2006/main">
               <a:ext uri="{FF2B5EF4-FFF2-40B4-BE49-F238E27FC236}">
-                <a16:creationId xmlns:a16="http://schemas.microsoft.com/office/drawing/2014/main" id="{1B71C445-843B-4711-A55E-7F72F3FF5B52}"/>
+                <a16:creationId xmlns:a16="http://schemas.microsoft.com/office/drawing/2014/main" id="{6DD9D47B-6F9E-4FBF-AF37-EDCCBE375D08}"/>
               </a:ext>
             </a:extLst>
           </p:cNvPr>
@@ -4290,7 +4335,7 @@
           <p:cNvPr id="2" name="">
             <a:extLst xmlns:a="http://schemas.openxmlformats.org/drawingml/2006/main">
               <a:ext uri="{FF2B5EF4-FFF2-40B4-BE49-F238E27FC236}">
-                <a16:creationId xmlns:a16="http://schemas.microsoft.com/office/drawing/2014/main" id="{EE98D4BB-9087-498C-A4B4-2010455C1C5A}"/>
+                <a16:creationId xmlns:a16="http://schemas.microsoft.com/office/drawing/2014/main" id="{E7F43D77-A442-41BC-B90A-322673E3C1F8}"/>
               </a:ext>
             </a:extLst>
           </p:cNvPr>
@@ -4347,7 +4392,7 @@
           <p:cNvPr id="3" name="">
             <a:extLst xmlns:a="http://schemas.openxmlformats.org/drawingml/2006/main">
               <a:ext uri="{FF2B5EF4-FFF2-40B4-BE49-F238E27FC236}">
-                <a16:creationId xmlns:a16="http://schemas.microsoft.com/office/drawing/2014/main" id="{F1C67441-C405-4D4A-80A5-99F361E79EBC}"/>
+                <a16:creationId xmlns:a16="http://schemas.microsoft.com/office/drawing/2014/main" id="{245DEA5F-4372-4BC3-BFFE-56D33DB538EB}"/>
               </a:ext>
             </a:extLst>
           </p:cNvPr>
@@ -4404,7 +4449,7 @@
           <p:cNvPr id="4" name="">
             <a:extLst xmlns:a="http://schemas.openxmlformats.org/drawingml/2006/main">
               <a:ext uri="{FF2B5EF4-FFF2-40B4-BE49-F238E27FC236}">
-                <a16:creationId xmlns:a16="http://schemas.microsoft.com/office/drawing/2014/main" id="{768C07A5-F5FA-4F8F-BB8E-552037E31D4D}"/>
+                <a16:creationId xmlns:a16="http://schemas.microsoft.com/office/drawing/2014/main" id="{52A9CD46-CD2C-45DC-87BE-AD10B1C14E01}"/>
               </a:ext>
             </a:extLst>
           </p:cNvPr>
@@ -4461,7 +4506,7 @@
           <p:cNvPr id="5" name="">
             <a:extLst xmlns:a="http://schemas.openxmlformats.org/drawingml/2006/main">
               <a:ext uri="{FF2B5EF4-FFF2-40B4-BE49-F238E27FC236}">
-                <a16:creationId xmlns:a16="http://schemas.microsoft.com/office/drawing/2014/main" id="{8CDC0232-3851-4FC1-BFD7-8839C40DDC7E}"/>
+                <a16:creationId xmlns:a16="http://schemas.microsoft.com/office/drawing/2014/main" id="{081AE785-7ED6-4E83-ADF9-C5CFCA78FC74}"/>
               </a:ext>
             </a:extLst>
           </p:cNvPr>
@@ -4518,7 +4563,7 @@
           <p:cNvPr id="6" name="">
             <a:extLst xmlns:a="http://schemas.openxmlformats.org/drawingml/2006/main">
               <a:ext uri="{FF2B5EF4-FFF2-40B4-BE49-F238E27FC236}">
-                <a16:creationId xmlns:a16="http://schemas.microsoft.com/office/drawing/2014/main" id="{B4A01696-B4E5-4D7B-8995-007676171D58}"/>
+                <a16:creationId xmlns:a16="http://schemas.microsoft.com/office/drawing/2014/main" id="{14266F4A-E38B-4E5D-966F-30E3D2A97DE6}"/>
               </a:ext>
             </a:extLst>
           </p:cNvPr>
@@ -4575,7 +4620,7 @@
           <p:cNvPr id="7" name="">
             <a:extLst xmlns:a="http://schemas.openxmlformats.org/drawingml/2006/main">
               <a:ext uri="{FF2B5EF4-FFF2-40B4-BE49-F238E27FC236}">
-                <a16:creationId xmlns:a16="http://schemas.microsoft.com/office/drawing/2014/main" id="{6497C896-21BD-4374-AE2E-E8C4714BA255}"/>
+                <a16:creationId xmlns:a16="http://schemas.microsoft.com/office/drawing/2014/main" id="{393939C9-C1B4-48A3-BFC9-99FC1488FD7D}"/>
               </a:ext>
             </a:extLst>
           </p:cNvPr>
@@ -4632,7 +4677,7 @@
           <p:cNvPr id="8" name="">
             <a:extLst xmlns:a="http://schemas.openxmlformats.org/drawingml/2006/main">
               <a:ext uri="{FF2B5EF4-FFF2-40B4-BE49-F238E27FC236}">
-                <a16:creationId xmlns:a16="http://schemas.microsoft.com/office/drawing/2014/main" id="{8F4367DD-F0F9-4BBF-A702-48511E69C426}"/>
+                <a16:creationId xmlns:a16="http://schemas.microsoft.com/office/drawing/2014/main" id="{3B27C6FA-4B55-4A97-8FB0-60A2B362C92D}"/>
               </a:ext>
             </a:extLst>
           </p:cNvPr>
@@ -4689,7 +4734,7 @@
           <p:cNvPr id="9" name="">
             <a:extLst xmlns:a="http://schemas.openxmlformats.org/drawingml/2006/main">
               <a:ext uri="{FF2B5EF4-FFF2-40B4-BE49-F238E27FC236}">
-                <a16:creationId xmlns:a16="http://schemas.microsoft.com/office/drawing/2014/main" id="{591F2B1B-81A2-47CE-976E-D08558D41478}"/>
+                <a16:creationId xmlns:a16="http://schemas.microsoft.com/office/drawing/2014/main" id="{13F9BA3C-1032-4BC6-AA3B-EDF916292DFB}"/>
               </a:ext>
             </a:extLst>
           </p:cNvPr>
@@ -4736,7 +4781,7 @@
                 <a:ea typeface="Arial"/>
                 <a:cs typeface="Arial"/>
               </a:rPr>
-              <a:t>9. September 2026     2 / 12</a:t>
+              <a:t>11. September 2026     2 / 12</a:t>
             </a:r>
           </a:p>
         </p:txBody>
@@ -4744,7 +4789,7 @@
     </p:spTree>
     <p:extLst>
       <p:ext uri="{BB962C8B-B14F-4D97-AF65-F5344CB8AC3E}">
-        <p14:creationId xmlns:p14="http://schemas.microsoft.com/office/powerpoint/2010/main" val="1351580016"/>
+        <p14:creationId xmlns:p14="http://schemas.microsoft.com/office/powerpoint/2010/main" val="285677216"/>
       </p:ext>
     </p:extLst>
   </p:cSld>
@@ -4775,7 +4820,7 @@
           <p:cNvPr id="10" name="">
             <a:extLst xmlns:a="http://schemas.openxmlformats.org/drawingml/2006/main">
               <a:ext uri="{FF2B5EF4-FFF2-40B4-BE49-F238E27FC236}">
-                <a16:creationId xmlns:a16="http://schemas.microsoft.com/office/drawing/2014/main" id="{7F3D14B1-88C9-4347-8C1C-8FB91AF9E654}"/>
+                <a16:creationId xmlns:a16="http://schemas.microsoft.com/office/drawing/2014/main" id="{F83D3632-3588-4640-8254-62BF3131CFF3}"/>
               </a:ext>
             </a:extLst>
           </p:cNvPr>
@@ -4832,7 +4877,7 @@
           <p:cNvPr id="2" name="">
             <a:extLst xmlns:a="http://schemas.openxmlformats.org/drawingml/2006/main">
               <a:ext uri="{FF2B5EF4-FFF2-40B4-BE49-F238E27FC236}">
-                <a16:creationId xmlns:a16="http://schemas.microsoft.com/office/drawing/2014/main" id="{44A740A8-BEFD-4FB6-842C-A423200F5079}"/>
+                <a16:creationId xmlns:a16="http://schemas.microsoft.com/office/drawing/2014/main" id="{058AD236-0BAB-4CC6-879E-E904E65BC3B6}"/>
               </a:ext>
             </a:extLst>
           </p:cNvPr>
@@ -4889,7 +4934,7 @@
           <p:cNvPr id="3" name="">
             <a:extLst xmlns:a="http://schemas.openxmlformats.org/drawingml/2006/main">
               <a:ext uri="{FF2B5EF4-FFF2-40B4-BE49-F238E27FC236}">
-                <a16:creationId xmlns:a16="http://schemas.microsoft.com/office/drawing/2014/main" id="{44004F6A-F853-4560-B706-1D62C1E6B2EA}"/>
+                <a16:creationId xmlns:a16="http://schemas.microsoft.com/office/drawing/2014/main" id="{D49D89FC-BC8C-4F64-99B4-F9923FB48D54}"/>
               </a:ext>
             </a:extLst>
           </p:cNvPr>
@@ -4946,7 +4991,7 @@
           <p:cNvPr id="4" name="">
             <a:extLst xmlns:a="http://schemas.openxmlformats.org/drawingml/2006/main">
               <a:ext uri="{FF2B5EF4-FFF2-40B4-BE49-F238E27FC236}">
-                <a16:creationId xmlns:a16="http://schemas.microsoft.com/office/drawing/2014/main" id="{6209B8E6-8F51-4524-840F-5EC00D6CD57C}"/>
+                <a16:creationId xmlns:a16="http://schemas.microsoft.com/office/drawing/2014/main" id="{A945137B-9AA6-485B-9E4F-36D570331E09}"/>
               </a:ext>
             </a:extLst>
           </p:cNvPr>
@@ -5003,7 +5048,7 @@
           <p:cNvPr id="5" name="">
             <a:extLst xmlns:a="http://schemas.openxmlformats.org/drawingml/2006/main">
               <a:ext uri="{FF2B5EF4-FFF2-40B4-BE49-F238E27FC236}">
-                <a16:creationId xmlns:a16="http://schemas.microsoft.com/office/drawing/2014/main" id="{711AEDF0-AFE9-4AAB-AA9C-C5536870A3AF}"/>
+                <a16:creationId xmlns:a16="http://schemas.microsoft.com/office/drawing/2014/main" id="{7F21602A-7BF8-461C-B4ED-FB3DBBB3DDBA}"/>
               </a:ext>
             </a:extLst>
           </p:cNvPr>
@@ -5060,7 +5105,7 @@
           <p:cNvPr id="6" name="">
             <a:extLst xmlns:a="http://schemas.openxmlformats.org/drawingml/2006/main">
               <a:ext uri="{FF2B5EF4-FFF2-40B4-BE49-F238E27FC236}">
-                <a16:creationId xmlns:a16="http://schemas.microsoft.com/office/drawing/2014/main" id="{AE1B1743-90AF-4B5E-953C-52C5BC5063B7}"/>
+                <a16:creationId xmlns:a16="http://schemas.microsoft.com/office/drawing/2014/main" id="{96590219-4A3B-4D28-8180-A7FB8176EBBD}"/>
               </a:ext>
             </a:extLst>
           </p:cNvPr>
@@ -5117,7 +5162,7 @@
           <p:cNvPr id="7" name="">
             <a:extLst xmlns:a="http://schemas.openxmlformats.org/drawingml/2006/main">
               <a:ext uri="{FF2B5EF4-FFF2-40B4-BE49-F238E27FC236}">
-                <a16:creationId xmlns:a16="http://schemas.microsoft.com/office/drawing/2014/main" id="{BED5A9AC-82B0-4F57-86D1-10359ADD5E0B}"/>
+                <a16:creationId xmlns:a16="http://schemas.microsoft.com/office/drawing/2014/main" id="{FBFC5017-BEEF-4028-B0FE-7FBDE96C9359}"/>
               </a:ext>
             </a:extLst>
           </p:cNvPr>
@@ -5174,7 +5219,7 @@
           <p:cNvPr id="8" name="">
             <a:extLst xmlns:a="http://schemas.openxmlformats.org/drawingml/2006/main">
               <a:ext uri="{FF2B5EF4-FFF2-40B4-BE49-F238E27FC236}">
-                <a16:creationId xmlns:a16="http://schemas.microsoft.com/office/drawing/2014/main" id="{664C1FC4-E4FF-4C74-AF63-973651B62A5F}"/>
+                <a16:creationId xmlns:a16="http://schemas.microsoft.com/office/drawing/2014/main" id="{C7CE00FA-17AF-41BF-9A48-6BA8CEF31E62}"/>
               </a:ext>
             </a:extLst>
           </p:cNvPr>
@@ -5231,7 +5276,7 @@
           <p:cNvPr id="9" name="">
             <a:extLst xmlns:a="http://schemas.openxmlformats.org/drawingml/2006/main">
               <a:ext uri="{FF2B5EF4-FFF2-40B4-BE49-F238E27FC236}">
-                <a16:creationId xmlns:a16="http://schemas.microsoft.com/office/drawing/2014/main" id="{E99CE2DB-388B-4F86-BE7D-69CF4FDCE258}"/>
+                <a16:creationId xmlns:a16="http://schemas.microsoft.com/office/drawing/2014/main" id="{56A2D7CC-2E8A-44AA-AD45-46C3227A0BC7}"/>
               </a:ext>
             </a:extLst>
           </p:cNvPr>
@@ -5278,7 +5323,7 @@
                 <a:ea typeface="Arial"/>
                 <a:cs typeface="Arial"/>
               </a:rPr>
-              <a:t>9. September 2026     3 / 12</a:t>
+              <a:t>11. September 2026     3 / 12</a:t>
             </a:r>
           </a:p>
         </p:txBody>
@@ -5286,7 +5331,7 @@
     </p:spTree>
     <p:extLst>
       <p:ext uri="{BB962C8B-B14F-4D97-AF65-F5344CB8AC3E}">
-        <p14:creationId xmlns:p14="http://schemas.microsoft.com/office/powerpoint/2010/main" val="1745129400"/>
+        <p14:creationId xmlns:p14="http://schemas.microsoft.com/office/powerpoint/2010/main" val="1319576331"/>
       </p:ext>
     </p:extLst>
   </p:cSld>
@@ -5317,7 +5362,7 @@
           <p:cNvPr id="5" name="">
             <a:extLst xmlns:a="http://schemas.openxmlformats.org/drawingml/2006/main">
               <a:ext uri="{FF2B5EF4-FFF2-40B4-BE49-F238E27FC236}">
-                <a16:creationId xmlns:a16="http://schemas.microsoft.com/office/drawing/2014/main" id="{B800DBE7-E7FA-4783-9E0F-07CE432285D7}"/>
+                <a16:creationId xmlns:a16="http://schemas.microsoft.com/office/drawing/2014/main" id="{FBA965D5-B9CF-48B1-AD59-432E908B5B3B}"/>
               </a:ext>
             </a:extLst>
           </p:cNvPr>
@@ -5374,7 +5419,7 @@
           <p:cNvPr id="2" name="">
             <a:extLst xmlns:a="http://schemas.openxmlformats.org/drawingml/2006/main">
               <a:ext uri="{FF2B5EF4-FFF2-40B4-BE49-F238E27FC236}">
-                <a16:creationId xmlns:a16="http://schemas.microsoft.com/office/drawing/2014/main" id="{FC8404F3-3CC2-4FC6-873D-ADCC128B4C10}"/>
+                <a16:creationId xmlns:a16="http://schemas.microsoft.com/office/drawing/2014/main" id="{0DF714D7-0113-4A7A-8AC0-86563234A506}"/>
               </a:ext>
             </a:extLst>
           </p:cNvPr>
@@ -5723,7 +5768,7 @@
           <p:cNvPr id="4" name="">
             <a:extLst xmlns:a="http://schemas.openxmlformats.org/drawingml/2006/main">
               <a:ext uri="{FF2B5EF4-FFF2-40B4-BE49-F238E27FC236}">
-                <a16:creationId xmlns:a16="http://schemas.microsoft.com/office/drawing/2014/main" id="{61F7C528-3CF3-4390-A9F2-DB58A11F057E}"/>
+                <a16:creationId xmlns:a16="http://schemas.microsoft.com/office/drawing/2014/main" id="{00C8B0F3-ABB0-40CD-B66E-8BDD7EE2EFDC}"/>
               </a:ext>
             </a:extLst>
           </p:cNvPr>
@@ -5770,7 +5815,7 @@
                 <a:ea typeface="Arial"/>
                 <a:cs typeface="Arial"/>
               </a:rPr>
-              <a:t>9. September 2026     4 / 12</a:t>
+              <a:t>11. September 2026     4 / 12</a:t>
             </a:r>
           </a:p>
         </p:txBody>
@@ -5778,7 +5823,7 @@
     </p:spTree>
     <p:extLst>
       <p:ext uri="{BB962C8B-B14F-4D97-AF65-F5344CB8AC3E}">
-        <p14:creationId xmlns:p14="http://schemas.microsoft.com/office/powerpoint/2010/main" val="746491945"/>
+        <p14:creationId xmlns:p14="http://schemas.microsoft.com/office/powerpoint/2010/main" val="459103881"/>
       </p:ext>
     </p:extLst>
   </p:cSld>
@@ -5809,7 +5854,7 @@
           <p:cNvPr id="5" name="">
             <a:extLst xmlns:a="http://schemas.openxmlformats.org/drawingml/2006/main">
               <a:ext uri="{FF2B5EF4-FFF2-40B4-BE49-F238E27FC236}">
-                <a16:creationId xmlns:a16="http://schemas.microsoft.com/office/drawing/2014/main" id="{04168D8B-5EAC-463B-A56B-DD7315A9A249}"/>
+                <a16:creationId xmlns:a16="http://schemas.microsoft.com/office/drawing/2014/main" id="{09792635-BB1C-40E7-9E0D-FFFCB9856625}"/>
               </a:ext>
             </a:extLst>
           </p:cNvPr>
@@ -5866,7 +5911,7 @@
           <p:cNvPr id="2" name="">
             <a:extLst xmlns:a="http://schemas.openxmlformats.org/drawingml/2006/main">
               <a:ext uri="{FF2B5EF4-FFF2-40B4-BE49-F238E27FC236}">
-                <a16:creationId xmlns:a16="http://schemas.microsoft.com/office/drawing/2014/main" id="{BCA1A113-6556-412B-B1EC-B4F2052FF569}"/>
+                <a16:creationId xmlns:a16="http://schemas.microsoft.com/office/drawing/2014/main" id="{1E9D3FDD-B7F2-4F49-AA25-6D1C731ED03B}"/>
               </a:ext>
             </a:extLst>
           </p:cNvPr>
@@ -6215,7 +6260,7 @@
           <p:cNvPr id="4" name="">
             <a:extLst xmlns:a="http://schemas.openxmlformats.org/drawingml/2006/main">
               <a:ext uri="{FF2B5EF4-FFF2-40B4-BE49-F238E27FC236}">
-                <a16:creationId xmlns:a16="http://schemas.microsoft.com/office/drawing/2014/main" id="{0478F6B1-91BF-48A1-86E7-C77BEAF554C7}"/>
+                <a16:creationId xmlns:a16="http://schemas.microsoft.com/office/drawing/2014/main" id="{4F2D33F2-4CF4-49FF-B7CB-C19687CDADCA}"/>
               </a:ext>
             </a:extLst>
           </p:cNvPr>
@@ -6262,7 +6307,7 @@
                 <a:ea typeface="Arial"/>
                 <a:cs typeface="Arial"/>
               </a:rPr>
-              <a:t>9. September 2026     5 / 12</a:t>
+              <a:t>11. September 2026     5 / 12</a:t>
             </a:r>
           </a:p>
         </p:txBody>
@@ -6270,7 +6315,7 @@
     </p:spTree>
     <p:extLst>
       <p:ext uri="{BB962C8B-B14F-4D97-AF65-F5344CB8AC3E}">
-        <p14:creationId xmlns:p14="http://schemas.microsoft.com/office/powerpoint/2010/main" val="1573645106"/>
+        <p14:creationId xmlns:p14="http://schemas.microsoft.com/office/powerpoint/2010/main" val="1806296699"/>
       </p:ext>
     </p:extLst>
   </p:cSld>
@@ -6301,7 +6346,7 @@
           <p:cNvPr id="10" name="">
             <a:extLst xmlns:a="http://schemas.openxmlformats.org/drawingml/2006/main">
               <a:ext uri="{FF2B5EF4-FFF2-40B4-BE49-F238E27FC236}">
-                <a16:creationId xmlns:a16="http://schemas.microsoft.com/office/drawing/2014/main" id="{DEFBCBED-7C01-49AB-8BFD-7C71C592FE7E}"/>
+                <a16:creationId xmlns:a16="http://schemas.microsoft.com/office/drawing/2014/main" id="{14FD5E2B-655D-4CB8-8EDC-DB48185DFC3E}"/>
               </a:ext>
             </a:extLst>
           </p:cNvPr>
@@ -6358,7 +6403,7 @@
           <p:cNvPr id="2" name="">
             <a:extLst xmlns:a="http://schemas.openxmlformats.org/drawingml/2006/main">
               <a:ext uri="{FF2B5EF4-FFF2-40B4-BE49-F238E27FC236}">
-                <a16:creationId xmlns:a16="http://schemas.microsoft.com/office/drawing/2014/main" id="{95FBE099-A253-4878-BDFC-414F15E44F3D}"/>
+                <a16:creationId xmlns:a16="http://schemas.microsoft.com/office/drawing/2014/main" id="{0ED6AD85-F65A-4337-A50A-452ADF296B1D}"/>
               </a:ext>
             </a:extLst>
           </p:cNvPr>
@@ -6415,7 +6460,7 @@
           <p:cNvPr id="3" name="">
             <a:extLst xmlns:a="http://schemas.openxmlformats.org/drawingml/2006/main">
               <a:ext uri="{FF2B5EF4-FFF2-40B4-BE49-F238E27FC236}">
-                <a16:creationId xmlns:a16="http://schemas.microsoft.com/office/drawing/2014/main" id="{AF54272A-6C66-448D-9E32-1D242162C98E}"/>
+                <a16:creationId xmlns:a16="http://schemas.microsoft.com/office/drawing/2014/main" id="{EF5BFD72-C72D-4385-BE0F-04242DD40BA9}"/>
               </a:ext>
             </a:extLst>
           </p:cNvPr>
@@ -6472,7 +6517,7 @@
           <p:cNvPr id="4" name="">
             <a:extLst xmlns:a="http://schemas.openxmlformats.org/drawingml/2006/main">
               <a:ext uri="{FF2B5EF4-FFF2-40B4-BE49-F238E27FC236}">
-                <a16:creationId xmlns:a16="http://schemas.microsoft.com/office/drawing/2014/main" id="{B9F125DC-EC06-423E-AEE9-F58267E9C8C2}"/>
+                <a16:creationId xmlns:a16="http://schemas.microsoft.com/office/drawing/2014/main" id="{AB1746AC-4E11-44BF-9E95-F479230B4E90}"/>
               </a:ext>
             </a:extLst>
           </p:cNvPr>
@@ -6529,7 +6574,7 @@
           <p:cNvPr id="5" name="">
             <a:extLst xmlns:a="http://schemas.openxmlformats.org/drawingml/2006/main">
               <a:ext uri="{FF2B5EF4-FFF2-40B4-BE49-F238E27FC236}">
-                <a16:creationId xmlns:a16="http://schemas.microsoft.com/office/drawing/2014/main" id="{7F710063-8088-486B-AFDC-B2D26962E256}"/>
+                <a16:creationId xmlns:a16="http://schemas.microsoft.com/office/drawing/2014/main" id="{54959F88-F274-415B-9013-2746BE6DE4C7}"/>
               </a:ext>
             </a:extLst>
           </p:cNvPr>
@@ -6586,7 +6631,7 @@
           <p:cNvPr id="6" name="">
             <a:extLst xmlns:a="http://schemas.openxmlformats.org/drawingml/2006/main">
               <a:ext uri="{FF2B5EF4-FFF2-40B4-BE49-F238E27FC236}">
-                <a16:creationId xmlns:a16="http://schemas.microsoft.com/office/drawing/2014/main" id="{BC9402C4-5DB0-46D2-AED6-F73EE5CD0DFA}"/>
+                <a16:creationId xmlns:a16="http://schemas.microsoft.com/office/drawing/2014/main" id="{06424F38-D688-44BA-B0FD-5AFB93E946B6}"/>
               </a:ext>
             </a:extLst>
           </p:cNvPr>
@@ -6643,7 +6688,7 @@
           <p:cNvPr id="7" name="">
             <a:extLst xmlns:a="http://schemas.openxmlformats.org/drawingml/2006/main">
               <a:ext uri="{FF2B5EF4-FFF2-40B4-BE49-F238E27FC236}">
-                <a16:creationId xmlns:a16="http://schemas.microsoft.com/office/drawing/2014/main" id="{4801C730-2BFE-4B57-A791-C774CCD4B769}"/>
+                <a16:creationId xmlns:a16="http://schemas.microsoft.com/office/drawing/2014/main" id="{5581F2CD-9A06-4F98-B475-CD0AA75B5D21}"/>
               </a:ext>
             </a:extLst>
           </p:cNvPr>
@@ -6700,7 +6745,7 @@
           <p:cNvPr id="8" name="">
             <a:extLst xmlns:a="http://schemas.openxmlformats.org/drawingml/2006/main">
               <a:ext uri="{FF2B5EF4-FFF2-40B4-BE49-F238E27FC236}">
-                <a16:creationId xmlns:a16="http://schemas.microsoft.com/office/drawing/2014/main" id="{1CAF6479-FE93-4DFB-8010-836554EE1794}"/>
+                <a16:creationId xmlns:a16="http://schemas.microsoft.com/office/drawing/2014/main" id="{36AEB776-1F07-4A25-8D29-A4DA937391CB}"/>
               </a:ext>
             </a:extLst>
           </p:cNvPr>
@@ -6757,7 +6802,7 @@
           <p:cNvPr id="9" name="">
             <a:extLst xmlns:a="http://schemas.openxmlformats.org/drawingml/2006/main">
               <a:ext uri="{FF2B5EF4-FFF2-40B4-BE49-F238E27FC236}">
-                <a16:creationId xmlns:a16="http://schemas.microsoft.com/office/drawing/2014/main" id="{497F6BFB-59ED-4D4B-8916-5A85D0139C35}"/>
+                <a16:creationId xmlns:a16="http://schemas.microsoft.com/office/drawing/2014/main" id="{CB856BFE-7120-4F31-9878-C4B7F06734A0}"/>
               </a:ext>
             </a:extLst>
           </p:cNvPr>
@@ -6804,7 +6849,7 @@
                 <a:ea typeface="Arial"/>
                 <a:cs typeface="Arial"/>
               </a:rPr>
-              <a:t>9. September 2026     6 / 12</a:t>
+              <a:t>11. September 2026     6 / 12</a:t>
             </a:r>
           </a:p>
         </p:txBody>
@@ -6812,7 +6857,7 @@
     </p:spTree>
     <p:extLst>
       <p:ext uri="{BB962C8B-B14F-4D97-AF65-F5344CB8AC3E}">
-        <p14:creationId xmlns:p14="http://schemas.microsoft.com/office/powerpoint/2010/main" val="1464354637"/>
+        <p14:creationId xmlns:p14="http://schemas.microsoft.com/office/powerpoint/2010/main" val="287149251"/>
       </p:ext>
     </p:extLst>
   </p:cSld>
@@ -6843,7 +6888,7 @@
           <p:cNvPr id="5" name="">
             <a:extLst xmlns:a="http://schemas.openxmlformats.org/drawingml/2006/main">
               <a:ext uri="{FF2B5EF4-FFF2-40B4-BE49-F238E27FC236}">
-                <a16:creationId xmlns:a16="http://schemas.microsoft.com/office/drawing/2014/main" id="{E9D2A33B-80C4-48CB-85E4-1D960C0461D4}"/>
+                <a16:creationId xmlns:a16="http://schemas.microsoft.com/office/drawing/2014/main" id="{A913DB3E-2FDE-404A-AD19-65D45133B8D4}"/>
               </a:ext>
             </a:extLst>
           </p:cNvPr>
@@ -6900,7 +6945,7 @@
           <p:cNvPr id="2" name="">
             <a:extLst xmlns:a="http://schemas.openxmlformats.org/drawingml/2006/main">
               <a:ext uri="{FF2B5EF4-FFF2-40B4-BE49-F238E27FC236}">
-                <a16:creationId xmlns:a16="http://schemas.microsoft.com/office/drawing/2014/main" id="{66D50DC4-F805-4503-B26C-A319B37F24F9}"/>
+                <a16:creationId xmlns:a16="http://schemas.microsoft.com/office/drawing/2014/main" id="{34CFA06D-384B-4C24-A87B-D09240E5DA17}"/>
               </a:ext>
             </a:extLst>
           </p:cNvPr>
@@ -7095,7 +7140,7 @@
                           <a:ea typeface="Arial"/>
                           <a:cs typeface="Arial"/>
                         </a:rPr>
-                        <a:t>Aufnahme und zentrale Statusanzeige</a:t>
+                        <a:t>Aktuelle Ergebnisse für drei Consumer</a:t>
                       </a:r>
                     </a:p>
                   </a:txBody>
@@ -7121,7 +7166,7 @@
                           <a:ea typeface="Arial"/>
                           <a:cs typeface="Arial"/>
                         </a:rPr>
-                        <a:t>Neue reale Anwendungsergebnisse</a:t>
+                        <a:t>Wiederholbarkeit und Befundbearbeitung</a:t>
                       </a:r>
                     </a:p>
                   </a:txBody>
@@ -7249,7 +7294,7 @@
           <p:cNvPr id="4" name="">
             <a:extLst xmlns:a="http://schemas.openxmlformats.org/drawingml/2006/main">
               <a:ext uri="{FF2B5EF4-FFF2-40B4-BE49-F238E27FC236}">
-                <a16:creationId xmlns:a16="http://schemas.microsoft.com/office/drawing/2014/main" id="{254F61BE-0DDC-4266-9B33-2245EC7F5767}"/>
+                <a16:creationId xmlns:a16="http://schemas.microsoft.com/office/drawing/2014/main" id="{CA06327E-63FF-4963-97B9-10B37933D2FD}"/>
               </a:ext>
             </a:extLst>
           </p:cNvPr>
@@ -7296,7 +7341,7 @@
                 <a:ea typeface="Arial"/>
                 <a:cs typeface="Arial"/>
               </a:rPr>
-              <a:t>9. September 2026     7 / 12</a:t>
+              <a:t>11. September 2026     7 / 12</a:t>
             </a:r>
           </a:p>
         </p:txBody>
@@ -7304,7 +7349,7 @@
     </p:spTree>
     <p:extLst>
       <p:ext uri="{BB962C8B-B14F-4D97-AF65-F5344CB8AC3E}">
-        <p14:creationId xmlns:p14="http://schemas.microsoft.com/office/powerpoint/2010/main" val="1061542251"/>
+        <p14:creationId xmlns:p14="http://schemas.microsoft.com/office/powerpoint/2010/main" val="1329226602"/>
       </p:ext>
     </p:extLst>
   </p:cSld>
@@ -7335,7 +7380,7 @@
           <p:cNvPr id="9" name="">
             <a:extLst xmlns:a="http://schemas.openxmlformats.org/drawingml/2006/main">
               <a:ext uri="{FF2B5EF4-FFF2-40B4-BE49-F238E27FC236}">
-                <a16:creationId xmlns:a16="http://schemas.microsoft.com/office/drawing/2014/main" id="{CAEDCA3A-7EE4-49D9-980F-105D54257AE3}"/>
+                <a16:creationId xmlns:a16="http://schemas.microsoft.com/office/drawing/2014/main" id="{B428EAEE-41D0-436C-BD7F-DEA2E3A1092D}"/>
               </a:ext>
             </a:extLst>
           </p:cNvPr>
@@ -7382,7 +7427,7 @@
                 <a:ea typeface="Arial"/>
                 <a:cs typeface="Arial"/>
               </a:rPr>
-              <a:t>Aussagekraft der Referenzläufe</a:t>
+              <a:t>Angenommene Anwendungsergebnisse</a:t>
             </a:r>
           </a:p>
         </p:txBody>
@@ -7392,7 +7437,7 @@
           <p:cNvPr id="2" name="">
             <a:extLst xmlns:a="http://schemas.openxmlformats.org/drawingml/2006/main">
               <a:ext uri="{FF2B5EF4-FFF2-40B4-BE49-F238E27FC236}">
-                <a16:creationId xmlns:a16="http://schemas.microsoft.com/office/drawing/2014/main" id="{2B1FDFFA-8E3D-4F81-A307-0DC871CA2F67}"/>
+                <a16:creationId xmlns:a16="http://schemas.microsoft.com/office/drawing/2014/main" id="{12FEADE7-6D16-4713-81A3-C41BB6E9239C}"/>
               </a:ext>
             </a:extLst>
           </p:cNvPr>
@@ -7439,7 +7484,7 @@
                 <a:ea typeface="Arial"/>
                 <a:cs typeface="Arial"/>
               </a:rPr>
-              <a:t>ha-CPsWMS am 15. Juli 2026</a:t>
+              <a:t>ha-CPsWMS am 11. September 2026</a:t>
             </a:r>
           </a:p>
         </p:txBody>
@@ -7449,7 +7494,7 @@
           <p:cNvPr id="3" name="">
             <a:extLst xmlns:a="http://schemas.openxmlformats.org/drawingml/2006/main">
               <a:ext uri="{FF2B5EF4-FFF2-40B4-BE49-F238E27FC236}">
-                <a16:creationId xmlns:a16="http://schemas.microsoft.com/office/drawing/2014/main" id="{61569220-1AED-4031-9EDD-0BAD4CEBC1BD}"/>
+                <a16:creationId xmlns:a16="http://schemas.microsoft.com/office/drawing/2014/main" id="{0AE53F7A-6DD6-4CEA-8BBD-D15AFFA86DF6}"/>
               </a:ext>
             </a:extLst>
           </p:cNvPr>
@@ -7506,7 +7551,7 @@
           <p:cNvPr id="4" name="">
             <a:extLst xmlns:a="http://schemas.openxmlformats.org/drawingml/2006/main">
               <a:ext uri="{FF2B5EF4-FFF2-40B4-BE49-F238E27FC236}">
-                <a16:creationId xmlns:a16="http://schemas.microsoft.com/office/drawing/2014/main" id="{398675B6-FAE6-4B8D-843F-821A76327D9D}"/>
+                <a16:creationId xmlns:a16="http://schemas.microsoft.com/office/drawing/2014/main" id="{8D564778-B6BF-4CD4-8353-FA852E2740FE}"/>
               </a:ext>
             </a:extLst>
           </p:cNvPr>
@@ -7553,7 +7598,7 @@
                 <a:ea typeface="Arial"/>
                 <a:cs typeface="Arial"/>
               </a:rPr>
-              <a:t>DevSecOps-Kontrollen bestanden</a:t>
+              <a:t>Anwendbare DevSecOps-Kontrollen bestanden</a:t>
             </a:r>
           </a:p>
         </p:txBody>
@@ -7563,7 +7608,7 @@
           <p:cNvPr id="5" name="">
             <a:extLst xmlns:a="http://schemas.openxmlformats.org/drawingml/2006/main">
               <a:ext uri="{FF2B5EF4-FFF2-40B4-BE49-F238E27FC236}">
-                <a16:creationId xmlns:a16="http://schemas.microsoft.com/office/drawing/2014/main" id="{36D6F57F-64B7-45BE-AB8F-035B320AF731}"/>
+                <a16:creationId xmlns:a16="http://schemas.microsoft.com/office/drawing/2014/main" id="{D0461BD5-D449-48FB-8592-72BDE856B67B}"/>
               </a:ext>
             </a:extLst>
           </p:cNvPr>
@@ -7620,7 +7665,7 @@
           <p:cNvPr id="6" name="">
             <a:extLst xmlns:a="http://schemas.openxmlformats.org/drawingml/2006/main">
               <a:ext uri="{FF2B5EF4-FFF2-40B4-BE49-F238E27FC236}">
-                <a16:creationId xmlns:a16="http://schemas.microsoft.com/office/drawing/2014/main" id="{AE5FD660-4CCB-4910-9520-03FAE87E746F}"/>
+                <a16:creationId xmlns:a16="http://schemas.microsoft.com/office/drawing/2014/main" id="{94E792FD-F003-43D2-BA37-35FE3FAA7998}"/>
               </a:ext>
             </a:extLst>
           </p:cNvPr>
@@ -7677,7 +7722,7 @@
           <p:cNvPr id="7" name="">
             <a:extLst xmlns:a="http://schemas.openxmlformats.org/drawingml/2006/main">
               <a:ext uri="{FF2B5EF4-FFF2-40B4-BE49-F238E27FC236}">
-                <a16:creationId xmlns:a16="http://schemas.microsoft.com/office/drawing/2014/main" id="{D9BBBA47-9391-42F0-82C9-ED44CCCC416F}"/>
+                <a16:creationId xmlns:a16="http://schemas.microsoft.com/office/drawing/2014/main" id="{F2AA9519-F6CC-41BE-A7A9-A8901EC5FEB0}"/>
               </a:ext>
             </a:extLst>
           </p:cNvPr>
@@ -7724,7 +7769,7 @@
                 <a:ea typeface="Arial"/>
                 <a:cs typeface="Arial"/>
               </a:rPr>
-              <a:t>Historische Ergebnisse belegen keine aktuelle Freigabe</a:t>
+              <a:t>Separater Replay-Befund bleibt offen · keine Produktionsfreigabe</a:t>
             </a:r>
           </a:p>
         </p:txBody>
@@ -7734,7 +7779,7 @@
           <p:cNvPr id="8" name="">
             <a:extLst xmlns:a="http://schemas.openxmlformats.org/drawingml/2006/main">
               <a:ext uri="{FF2B5EF4-FFF2-40B4-BE49-F238E27FC236}">
-                <a16:creationId xmlns:a16="http://schemas.microsoft.com/office/drawing/2014/main" id="{5CEB971A-5100-4D14-AD60-8DB746A8AB6A}"/>
+                <a16:creationId xmlns:a16="http://schemas.microsoft.com/office/drawing/2014/main" id="{7B7A4223-9A82-4DD4-98C4-4C4D26BF5279}"/>
               </a:ext>
             </a:extLst>
           </p:cNvPr>
@@ -7781,7 +7826,7 @@
                 <a:ea typeface="Arial"/>
                 <a:cs typeface="Arial"/>
               </a:rPr>
-              <a:t>9. September 2026     8 / 12</a:t>
+              <a:t>11. September 2026     8 / 12</a:t>
             </a:r>
           </a:p>
         </p:txBody>
@@ -7789,7 +7834,7 @@
     </p:spTree>
     <p:extLst>
       <p:ext uri="{BB962C8B-B14F-4D97-AF65-F5344CB8AC3E}">
-        <p14:creationId xmlns:p14="http://schemas.microsoft.com/office/powerpoint/2010/main" val="1787096580"/>
+        <p14:creationId xmlns:p14="http://schemas.microsoft.com/office/powerpoint/2010/main" val="1323425312"/>
       </p:ext>
     </p:extLst>
   </p:cSld>
@@ -7820,7 +7865,7 @@
           <p:cNvPr id="10" name="">
             <a:extLst xmlns:a="http://schemas.openxmlformats.org/drawingml/2006/main">
               <a:ext uri="{FF2B5EF4-FFF2-40B4-BE49-F238E27FC236}">
-                <a16:creationId xmlns:a16="http://schemas.microsoft.com/office/drawing/2014/main" id="{0D6C05F8-46A0-4486-A111-CD823A14074F}"/>
+                <a16:creationId xmlns:a16="http://schemas.microsoft.com/office/drawing/2014/main" id="{A15884AA-11C2-4B5E-B9AA-D869C5CB89D6}"/>
               </a:ext>
             </a:extLst>
           </p:cNvPr>
@@ -7877,7 +7922,7 @@
           <p:cNvPr id="2" name="">
             <a:extLst xmlns:a="http://schemas.openxmlformats.org/drawingml/2006/main">
               <a:ext uri="{FF2B5EF4-FFF2-40B4-BE49-F238E27FC236}">
-                <a16:creationId xmlns:a16="http://schemas.microsoft.com/office/drawing/2014/main" id="{87CCBBF9-FD30-4771-963E-3D180C034FAF}"/>
+                <a16:creationId xmlns:a16="http://schemas.microsoft.com/office/drawing/2014/main" id="{4CC5FB41-C9F0-4222-AC12-A8FD42627A77}"/>
               </a:ext>
             </a:extLst>
           </p:cNvPr>
@@ -7934,7 +7979,7 @@
           <p:cNvPr id="3" name="">
             <a:extLst xmlns:a="http://schemas.openxmlformats.org/drawingml/2006/main">
               <a:ext uri="{FF2B5EF4-FFF2-40B4-BE49-F238E27FC236}">
-                <a16:creationId xmlns:a16="http://schemas.microsoft.com/office/drawing/2014/main" id="{B4558D93-66B4-4F68-A8A2-B1120E907001}"/>
+                <a16:creationId xmlns:a16="http://schemas.microsoft.com/office/drawing/2014/main" id="{CD1C77A3-35AC-4D91-8BAD-43377ED94866}"/>
               </a:ext>
             </a:extLst>
           </p:cNvPr>
@@ -7991,7 +8036,7 @@
           <p:cNvPr id="4" name="">
             <a:extLst xmlns:a="http://schemas.openxmlformats.org/drawingml/2006/main">
               <a:ext uri="{FF2B5EF4-FFF2-40B4-BE49-F238E27FC236}">
-                <a16:creationId xmlns:a16="http://schemas.microsoft.com/office/drawing/2014/main" id="{B76962DB-B955-49F4-9CEA-CDF1C25C18B0}"/>
+                <a16:creationId xmlns:a16="http://schemas.microsoft.com/office/drawing/2014/main" id="{5A16A96C-C5FD-44F9-85EB-6E3866DC4376}"/>
               </a:ext>
             </a:extLst>
           </p:cNvPr>
@@ -8048,7 +8093,7 @@
           <p:cNvPr id="5" name="">
             <a:extLst xmlns:a="http://schemas.openxmlformats.org/drawingml/2006/main">
               <a:ext uri="{FF2B5EF4-FFF2-40B4-BE49-F238E27FC236}">
-                <a16:creationId xmlns:a16="http://schemas.microsoft.com/office/drawing/2014/main" id="{9571D4F1-B184-4E18-9BEC-F9F3E23C6C6C}"/>
+                <a16:creationId xmlns:a16="http://schemas.microsoft.com/office/drawing/2014/main" id="{28E0CABC-AA8D-4912-AEC7-AD33312B4CE1}"/>
               </a:ext>
             </a:extLst>
           </p:cNvPr>
@@ -8105,7 +8150,7 @@
           <p:cNvPr id="6" name="">
             <a:extLst xmlns:a="http://schemas.openxmlformats.org/drawingml/2006/main">
               <a:ext uri="{FF2B5EF4-FFF2-40B4-BE49-F238E27FC236}">
-                <a16:creationId xmlns:a16="http://schemas.microsoft.com/office/drawing/2014/main" id="{48D2242B-7B48-487E-B813-EE39E62A1E0A}"/>
+                <a16:creationId xmlns:a16="http://schemas.microsoft.com/office/drawing/2014/main" id="{51A075EF-48D7-4E37-8323-85C1A128E12F}"/>
               </a:ext>
             </a:extLst>
           </p:cNvPr>
@@ -8162,7 +8207,7 @@
           <p:cNvPr id="7" name="">
             <a:extLst xmlns:a="http://schemas.openxmlformats.org/drawingml/2006/main">
               <a:ext uri="{FF2B5EF4-FFF2-40B4-BE49-F238E27FC236}">
-                <a16:creationId xmlns:a16="http://schemas.microsoft.com/office/drawing/2014/main" id="{75209B4B-3BB9-41A8-9300-0A34AAE084C9}"/>
+                <a16:creationId xmlns:a16="http://schemas.microsoft.com/office/drawing/2014/main" id="{8A1865D9-4F48-40AD-BCEE-3113DD8311D4}"/>
               </a:ext>
             </a:extLst>
           </p:cNvPr>
@@ -8219,7 +8264,7 @@
           <p:cNvPr id="8" name="">
             <a:extLst xmlns:a="http://schemas.openxmlformats.org/drawingml/2006/main">
               <a:ext uri="{FF2B5EF4-FFF2-40B4-BE49-F238E27FC236}">
-                <a16:creationId xmlns:a16="http://schemas.microsoft.com/office/drawing/2014/main" id="{2B265917-57C5-455F-BA67-206BEEF71AA4}"/>
+                <a16:creationId xmlns:a16="http://schemas.microsoft.com/office/drawing/2014/main" id="{B3F1D4E1-0E6E-4207-8157-BA68BAE9D692}"/>
               </a:ext>
             </a:extLst>
           </p:cNvPr>
@@ -8276,7 +8321,7 @@
           <p:cNvPr id="9" name="">
             <a:extLst xmlns:a="http://schemas.openxmlformats.org/drawingml/2006/main">
               <a:ext uri="{FF2B5EF4-FFF2-40B4-BE49-F238E27FC236}">
-                <a16:creationId xmlns:a16="http://schemas.microsoft.com/office/drawing/2014/main" id="{0770028C-FD86-4AC9-865C-D4B4FFADE6DB}"/>
+                <a16:creationId xmlns:a16="http://schemas.microsoft.com/office/drawing/2014/main" id="{A1520056-F59A-4B47-986D-7F532249EA97}"/>
               </a:ext>
             </a:extLst>
           </p:cNvPr>
@@ -8323,7 +8368,7 @@
                 <a:ea typeface="Arial"/>
                 <a:cs typeface="Arial"/>
               </a:rPr>
-              <a:t>9. September 2026     9 / 12</a:t>
+              <a:t>11. September 2026     9 / 12</a:t>
             </a:r>
           </a:p>
         </p:txBody>
@@ -8331,7 +8376,7 @@
     </p:spTree>
     <p:extLst>
       <p:ext uri="{BB962C8B-B14F-4D97-AF65-F5344CB8AC3E}">
-        <p14:creationId xmlns:p14="http://schemas.microsoft.com/office/powerpoint/2010/main" val="1547841810"/>
+        <p14:creationId xmlns:p14="http://schemas.microsoft.com/office/powerpoint/2010/main" val="651403597"/>
       </p:ext>
     </p:extLst>
   </p:cSld>

</xml_diff>